<commit_message>
Final touches on Sources_and_Monitors
</commit_message>
<xml_diff>
--- a/22_September_Tuesday/morning_sources_detectors/02_Sources_Monitors/McStas_McXtrace_Sources_and_Monitors.pptx
+++ b/22_September_Tuesday/morning_sources_detectors/02_Sources_Monitors/McStas_McXtrace_Sources_and_Monitors.pptx
@@ -5,7 +5,7 @@
     <p:sldMasterId id="2147483648" r:id="rId1"/>
   </p:sldMasterIdLst>
   <p:notesMasterIdLst>
-    <p:notesMasterId r:id="rId19"/>
+    <p:notesMasterId r:id="rId20"/>
   </p:notesMasterIdLst>
   <p:sldIdLst>
     <p:sldId id="256" r:id="rId2"/>
@@ -23,8 +23,9 @@
     <p:sldId id="268" r:id="rId14"/>
     <p:sldId id="269" r:id="rId15"/>
     <p:sldId id="270" r:id="rId16"/>
-    <p:sldId id="271" r:id="rId17"/>
-    <p:sldId id="272" r:id="rId18"/>
+    <p:sldId id="273" r:id="rId17"/>
+    <p:sldId id="271" r:id="rId18"/>
+    <p:sldId id="272" r:id="rId19"/>
   </p:sldIdLst>
   <p:sldSz cx="12192000" cy="6858000"/>
   <p:notesSz cx="6858000" cy="12192000"/>
@@ -846,7 +847,13 @@
   <p:cSld>
     <p:spTree>
       <p:nvGrpSpPr>
-        <p:cNvPr id="1" name=""/>
+        <p:cNvPr id="1" name="">
+          <a:extLst>
+            <a:ext uri="{FF2B5EF4-FFF2-40B4-BE49-F238E27FC236}">
+              <a16:creationId xmlns:a16="http://schemas.microsoft.com/office/drawing/2014/main" id="{3DBFC2E0-BE72-BBB6-AE90-3EDB2CB100AC}"/>
+            </a:ext>
+          </a:extLst>
+        </p:cNvPr>
         <p:cNvGrpSpPr/>
         <p:nvPr/>
       </p:nvGrpSpPr>
@@ -860,7 +867,13 @@
       </p:grpSpPr>
       <p:sp>
         <p:nvSpPr>
-          <p:cNvPr id="2" name="Slide Image Placeholder 1"/>
+          <p:cNvPr id="2" name="Slide Image Placeholder 1">
+            <a:extLst>
+              <a:ext uri="{FF2B5EF4-FFF2-40B4-BE49-F238E27FC236}">
+                <a16:creationId xmlns:a16="http://schemas.microsoft.com/office/drawing/2014/main" id="{6177B240-A418-EDE2-8010-859676E467B3}"/>
+              </a:ext>
+            </a:extLst>
+          </p:cNvPr>
           <p:cNvSpPr>
             <a:spLocks noGrp="1" noRot="1" noChangeAspect="1"/>
           </p:cNvSpPr>
@@ -872,7 +885,13 @@
       </p:sp>
       <p:sp>
         <p:nvSpPr>
-          <p:cNvPr id="3" name="Notes Placeholder 2"/>
+          <p:cNvPr id="3" name="Notes Placeholder 2">
+            <a:extLst>
+              <a:ext uri="{FF2B5EF4-FFF2-40B4-BE49-F238E27FC236}">
+                <a16:creationId xmlns:a16="http://schemas.microsoft.com/office/drawing/2014/main" id="{571D5831-77ED-9150-07FD-AD6BCDF4793B}"/>
+              </a:ext>
+            </a:extLst>
+          </p:cNvPr>
           <p:cNvSpPr>
             <a:spLocks noGrp="1"/>
           </p:cNvSpPr>
@@ -891,7 +910,13 @@
       </p:sp>
       <p:sp>
         <p:nvSpPr>
-          <p:cNvPr id="4" name="Slide Number Placeholder 3"/>
+          <p:cNvPr id="4" name="Slide Number Placeholder 3">
+            <a:extLst>
+              <a:ext uri="{FF2B5EF4-FFF2-40B4-BE49-F238E27FC236}">
+                <a16:creationId xmlns:a16="http://schemas.microsoft.com/office/drawing/2014/main" id="{4BAC81E7-F7E4-7BE6-E6AD-142DD605765B}"/>
+              </a:ext>
+            </a:extLst>
+          </p:cNvPr>
           <p:cNvSpPr>
             <a:spLocks noGrp="1"/>
           </p:cNvSpPr>
@@ -915,7 +940,7 @@
     </p:spTree>
     <p:extLst>
       <p:ext uri="{BB962C8B-B14F-4D97-AF65-F5344CB8AC3E}">
-        <p14:creationId xmlns:p14="http://schemas.microsoft.com/office/powerpoint/2010/main" val="1024086991"/>
+        <p14:creationId xmlns:p14="http://schemas.microsoft.com/office/powerpoint/2010/main" val="1396205424"/>
       </p:ext>
     </p:extLst>
   </p:cSld>
@@ -991,6 +1016,90 @@
             <a:fld id="{F7021451-1387-4CA6-816F-3879F97B5CBC}" type="slidenum">
               <a:rPr lang="en-US"/>
               <a:t>17</a:t>
+            </a:fld>
+            <a:endParaRPr lang="en-US"/>
+          </a:p>
+        </p:txBody>
+      </p:sp>
+    </p:spTree>
+    <p:extLst>
+      <p:ext uri="{BB962C8B-B14F-4D97-AF65-F5344CB8AC3E}">
+        <p14:creationId xmlns:p14="http://schemas.microsoft.com/office/powerpoint/2010/main" val="1024086991"/>
+      </p:ext>
+    </p:extLst>
+  </p:cSld>
+  <p:clrMapOvr>
+    <a:masterClrMapping/>
+  </p:clrMapOvr>
+</p:notes>
+</file>
+
+<file path=ppt/notesSlides/notesSlide18.xml><?xml version="1.0" encoding="utf-8"?>
+<p:notes xmlns:a="http://schemas.openxmlformats.org/drawingml/2006/main" xmlns:r="http://schemas.openxmlformats.org/officeDocument/2006/relationships" xmlns:p="http://schemas.openxmlformats.org/presentationml/2006/main">
+  <p:cSld>
+    <p:spTree>
+      <p:nvGrpSpPr>
+        <p:cNvPr id="1" name=""/>
+        <p:cNvGrpSpPr/>
+        <p:nvPr/>
+      </p:nvGrpSpPr>
+      <p:grpSpPr>
+        <a:xfrm>
+          <a:off x="0" y="0"/>
+          <a:ext cx="0" cy="0"/>
+          <a:chOff x="0" y="0"/>
+          <a:chExt cx="0" cy="0"/>
+        </a:xfrm>
+      </p:grpSpPr>
+      <p:sp>
+        <p:nvSpPr>
+          <p:cNvPr id="2" name="Slide Image Placeholder 1"/>
+          <p:cNvSpPr>
+            <a:spLocks noGrp="1" noRot="1" noChangeAspect="1"/>
+          </p:cNvSpPr>
+          <p:nvPr>
+            <p:ph type="sldImg"/>
+          </p:nvPr>
+        </p:nvSpPr>
+        <p:spPr/>
+      </p:sp>
+      <p:sp>
+        <p:nvSpPr>
+          <p:cNvPr id="3" name="Notes Placeholder 2"/>
+          <p:cNvSpPr>
+            <a:spLocks noGrp="1"/>
+          </p:cNvSpPr>
+          <p:nvPr>
+            <p:ph type="body" idx="1"/>
+          </p:nvPr>
+        </p:nvSpPr>
+        <p:spPr/>
+        <p:txBody>
+          <a:bodyPr/>
+          <a:lstStyle/>
+          <a:p>
+            <a:endParaRPr lang="en-US" dirty="0"/>
+          </a:p>
+        </p:txBody>
+      </p:sp>
+      <p:sp>
+        <p:nvSpPr>
+          <p:cNvPr id="4" name="Slide Number Placeholder 3"/>
+          <p:cNvSpPr>
+            <a:spLocks noGrp="1"/>
+          </p:cNvSpPr>
+          <p:nvPr>
+            <p:ph type="sldNum" sz="quarter" idx="10"/>
+          </p:nvPr>
+        </p:nvSpPr>
+        <p:spPr/>
+        <p:txBody>
+          <a:bodyPr/>
+          <a:lstStyle/>
+          <a:p>
+            <a:fld id="{F7021451-1387-4CA6-816F-3879F97B5CBC}" type="slidenum">
+              <a:rPr lang="en-US"/>
+              <a:t>18</a:t>
             </a:fld>
             <a:endParaRPr lang="en-US"/>
           </a:p>
@@ -2738,11 +2847,10 @@
           <a:bodyPr wrap="square" rtlCol="0" anchor="ctr"/>
           <a:lstStyle/>
           <a:p>
-            <a:pPr marL="0" indent="0">
+            <a:pPr>
               <a:lnSpc>
                 <a:spcPct val="125000"/>
               </a:lnSpc>
-              <a:buNone/>
             </a:pPr>
             <a:r>
               <a:rPr lang="en-US" sz="1200" dirty="0">
@@ -2753,7 +2861,7 @@
                 <a:ea typeface="Calibri" pitchFamily="34" charset="-122"/>
                 <a:cs typeface="Calibri" pitchFamily="34" charset="-120"/>
               </a:rPr>
-              <a:t>Use a continuous source, and force an infinitely short pulse: t = 0 for every ray, added via an </a:t>
+              <a:t>Use a continuous source and force an infinitely short pulse: t = 0 or define a short pulse via a rand01() for every ray within an </a:t>
             </a:r>
             <a:r>
               <a:rPr lang="en-US" sz="1200" b="1" dirty="0">
@@ -2882,7 +2990,29 @@
                 <a:ea typeface="Courier New" pitchFamily="34" charset="-122"/>
                 <a:cs typeface="Courier New" pitchFamily="34" charset="-120"/>
               </a:rPr>
-              <a:t>  t = 0;
+              <a:t>  t = 10e-3*rand01(); // 1 </a:t>
+            </a:r>
+            <a:r>
+              <a:rPr lang="en-US" sz="1250" dirty="0" err="1">
+                <a:solidFill>
+                  <a:srgbClr val="FFD79A"/>
+                </a:solidFill>
+                <a:latin typeface="Courier New" pitchFamily="34" charset="0"/>
+                <a:ea typeface="Courier New" pitchFamily="34" charset="-122"/>
+                <a:cs typeface="Courier New" pitchFamily="34" charset="-120"/>
+              </a:rPr>
+              <a:t>ms</a:t>
+            </a:r>
+            <a:r>
+              <a:rPr lang="en-US" sz="1250" dirty="0">
+                <a:solidFill>
+                  <a:srgbClr val="FFD79A"/>
+                </a:solidFill>
+                <a:latin typeface="Courier New" pitchFamily="34" charset="0"/>
+                <a:ea typeface="Courier New" pitchFamily="34" charset="-122"/>
+                <a:cs typeface="Courier New" pitchFamily="34" charset="-120"/>
+              </a:rPr>
+              <a:t> square pulse
 </a:t>
             </a:r>
             <a:r>
@@ -3718,7 +3848,7 @@
         <p:spPr>
           <a:xfrm>
             <a:off x="548640" y="5074920"/>
-            <a:ext cx="11064240" cy="777240"/>
+            <a:ext cx="11064240" cy="1041044"/>
           </a:xfrm>
           <a:prstGeom prst="roundRect">
             <a:avLst>
@@ -3734,7 +3864,7 @@
           <a:bodyPr/>
           <a:lstStyle/>
           <a:p>
-            <a:endParaRPr lang="en-DK"/>
+            <a:endParaRPr lang="en-DK" dirty="0"/>
           </a:p>
         </p:txBody>
       </p:sp>
@@ -3747,7 +3877,7 @@
         <p:spPr>
           <a:xfrm>
             <a:off x="822960" y="5074920"/>
-            <a:ext cx="10515600" cy="777240"/>
+            <a:ext cx="10515600" cy="1041044"/>
           </a:xfrm>
           <a:prstGeom prst="rect">
             <a:avLst/>
@@ -3783,6 +3913,43 @@
                 <a:cs typeface="Calibri" pitchFamily="34" charset="-120"/>
               </a:rPr>
               <a:t>“we refer to both indistinguishably as monitors” — the component is the same, only the parameters you give it change its role.</a:t>
+            </a:r>
+          </a:p>
+          <a:p>
+            <a:pPr marL="0" indent="0">
+              <a:buNone/>
+            </a:pPr>
+            <a:endParaRPr lang="en-US" sz="1250" dirty="0">
+              <a:solidFill>
+                <a:srgbClr val="20242B"/>
+              </a:solidFill>
+              <a:latin typeface="Calibri" pitchFamily="34" charset="0"/>
+              <a:ea typeface="Calibri" pitchFamily="34" charset="-122"/>
+              <a:cs typeface="Calibri" pitchFamily="34" charset="-120"/>
+            </a:endParaRPr>
+          </a:p>
+          <a:p>
+            <a:r>
+              <a:rPr lang="en-US" sz="1250" b="1" dirty="0">
+                <a:solidFill>
+                  <a:srgbClr val="12506B"/>
+                </a:solidFill>
+                <a:latin typeface="Calibri" pitchFamily="34" charset="0"/>
+                <a:ea typeface="Calibri" pitchFamily="34" charset="-122"/>
+                <a:cs typeface="Calibri" pitchFamily="34" charset="-120"/>
+              </a:rPr>
+              <a:t>Simulation of ’real’ detection-physics is an exception: </a:t>
+            </a:r>
+            <a:r>
+              <a:rPr lang="en-US" sz="1250" dirty="0">
+                <a:solidFill>
+                  <a:srgbClr val="20242B"/>
+                </a:solidFill>
+                <a:latin typeface="Calibri" pitchFamily="34" charset="0"/>
+                <a:ea typeface="Calibri" pitchFamily="34" charset="-122"/>
+                <a:cs typeface="Calibri" pitchFamily="34" charset="-120"/>
+              </a:rPr>
+              <a:t>“we leave that to expert-codes such as Geant4” — measurement is by default ”magic / for free”</a:t>
             </a:r>
             <a:endParaRPr lang="en-US" sz="1250" dirty="0"/>
           </a:p>
@@ -6222,6 +6389,971 @@
           </a:p>
         </p:txBody>
       </p:sp>
+      <p:grpSp>
+        <p:nvGrpSpPr>
+          <p:cNvPr id="22" name="Group 21">
+            <a:extLst>
+              <a:ext uri="{FF2B5EF4-FFF2-40B4-BE49-F238E27FC236}">
+                <a16:creationId xmlns:a16="http://schemas.microsoft.com/office/drawing/2014/main" id="{1A323E4A-D47D-FF29-39F5-560042114116}"/>
+              </a:ext>
+            </a:extLst>
+          </p:cNvPr>
+          <p:cNvGrpSpPr/>
+          <p:nvPr/>
+        </p:nvGrpSpPr>
+        <p:grpSpPr>
+          <a:xfrm>
+            <a:off x="59967" y="4445351"/>
+            <a:ext cx="6988437" cy="1818289"/>
+            <a:chOff x="2857849" y="2136246"/>
+            <a:chExt cx="6988437" cy="1818289"/>
+          </a:xfrm>
+        </p:grpSpPr>
+        <p:sp>
+          <p:nvSpPr>
+            <p:cNvPr id="23" name="Imagine a histogram, e.g. I(λ)…">
+              <a:extLst>
+                <a:ext uri="{FF2B5EF4-FFF2-40B4-BE49-F238E27FC236}">
+                  <a16:creationId xmlns:a16="http://schemas.microsoft.com/office/drawing/2014/main" id="{0DC3950C-BD47-5D81-A488-556125C79D1F}"/>
+                </a:ext>
+              </a:extLst>
+            </p:cNvPr>
+            <p:cNvSpPr txBox="1"/>
+            <p:nvPr/>
+          </p:nvSpPr>
+          <p:spPr>
+            <a:xfrm>
+              <a:off x="2857849" y="2136246"/>
+              <a:ext cx="6988437" cy="1597232"/>
+            </a:xfrm>
+            <a:prstGeom prst="rect">
+              <a:avLst/>
+            </a:prstGeom>
+            <a:ln w="12700">
+              <a:miter lim="400000"/>
+            </a:ln>
+            <a:extLst>
+              <a:ext uri="{C572A759-6A51-4108-AA02-DFA0A04FC94B}">
+                <ma14:wrappingTextBoxFlag xmlns="" xmlns:m="http://schemas.openxmlformats.org/officeDocument/2006/math" xmlns:a14="http://schemas.microsoft.com/office/drawing/2010/main" xmlns:ma14="http://schemas.microsoft.com/office/mac/drawingml/2011/main" val="1"/>
+              </a:ext>
+            </a:extLst>
+          </p:spPr>
+          <p:txBody>
+            <a:bodyPr lIns="0" tIns="0" rIns="0" bIns="0">
+              <a:spAutoFit/>
+            </a:bodyPr>
+            <a:lstStyle/>
+            <a:p>
+              <a:pPr defTabSz="914437">
+                <a:spcBef>
+                  <a:spcPts val="363"/>
+                </a:spcBef>
+                <a:defRPr sz="1600" spc="0"/>
+              </a:pPr>
+              <a:endParaRPr sz="1452" dirty="0"/>
+            </a:p>
+            <a:p>
+              <a:pPr defTabSz="914437">
+                <a:spcBef>
+                  <a:spcPts val="363"/>
+                </a:spcBef>
+                <a:defRPr sz="1600" spc="0"/>
+              </a:pPr>
+              <a:endParaRPr sz="1452" dirty="0"/>
+            </a:p>
+            <a:p>
+              <a:pPr defTabSz="914437">
+                <a:spcBef>
+                  <a:spcPts val="363"/>
+                </a:spcBef>
+                <a:defRPr sz="1600" spc="0"/>
+              </a:pPr>
+              <a:endParaRPr sz="1452" dirty="0"/>
+            </a:p>
+            <a:p>
+              <a:pPr defTabSz="914437">
+                <a:spcBef>
+                  <a:spcPts val="363"/>
+                </a:spcBef>
+                <a:defRPr sz="1600" spc="0"/>
+              </a:pPr>
+              <a:endParaRPr sz="1452" dirty="0"/>
+            </a:p>
+            <a:p>
+              <a:pPr defTabSz="914437">
+                <a:spcBef>
+                  <a:spcPts val="363"/>
+                </a:spcBef>
+                <a:defRPr sz="1600" spc="0"/>
+              </a:pPr>
+              <a:endParaRPr sz="1452" dirty="0"/>
+            </a:p>
+            <a:p>
+              <a:pPr defTabSz="914437">
+                <a:spcBef>
+                  <a:spcPts val="363"/>
+                </a:spcBef>
+                <a:defRPr sz="1600" spc="0"/>
+              </a:pPr>
+              <a:endParaRPr sz="1452" dirty="0"/>
+            </a:p>
+          </p:txBody>
+        </p:sp>
+        <p:sp>
+          <p:nvSpPr>
+            <p:cNvPr id="24" name="Rectangle">
+              <a:extLst>
+                <a:ext uri="{FF2B5EF4-FFF2-40B4-BE49-F238E27FC236}">
+                  <a16:creationId xmlns:a16="http://schemas.microsoft.com/office/drawing/2014/main" id="{0AD3B7E2-92F7-7F57-8D4B-680B5ADD5F34}"/>
+                </a:ext>
+              </a:extLst>
+            </p:cNvPr>
+            <p:cNvSpPr/>
+            <p:nvPr/>
+          </p:nvSpPr>
+          <p:spPr>
+            <a:xfrm>
+              <a:off x="4206797" y="2870562"/>
+              <a:ext cx="1725295" cy="121847"/>
+            </a:xfrm>
+            <a:prstGeom prst="rect">
+              <a:avLst/>
+            </a:prstGeom>
+            <a:solidFill>
+              <a:srgbClr val="FFFFFF"/>
+            </a:solidFill>
+            <a:ln w="3175">
+              <a:solidFill>
+                <a:srgbClr val="990000"/>
+              </a:solidFill>
+            </a:ln>
+          </p:spPr>
+          <p:txBody>
+            <a:bodyPr lIns="35122" tIns="35122" rIns="35122" bIns="35122" anchor="ctr"/>
+            <a:lstStyle/>
+            <a:p>
+              <a:pPr defTabSz="914437">
+                <a:spcBef>
+                  <a:spcPts val="908"/>
+                </a:spcBef>
+                <a:defRPr sz="1600"/>
+              </a:pPr>
+              <a:endParaRPr sz="1452"/>
+            </a:p>
+          </p:txBody>
+        </p:sp>
+        <p:sp>
+          <p:nvSpPr>
+            <p:cNvPr id="25" name="Rectangle">
+              <a:extLst>
+                <a:ext uri="{FF2B5EF4-FFF2-40B4-BE49-F238E27FC236}">
+                  <a16:creationId xmlns:a16="http://schemas.microsoft.com/office/drawing/2014/main" id="{7DAD745E-9785-B854-66BC-EB7220016EED}"/>
+                </a:ext>
+              </a:extLst>
+            </p:cNvPr>
+            <p:cNvSpPr/>
+            <p:nvPr/>
+          </p:nvSpPr>
+          <p:spPr>
+            <a:xfrm>
+              <a:off x="4206797" y="2871103"/>
+              <a:ext cx="104286" cy="120766"/>
+            </a:xfrm>
+            <a:prstGeom prst="rect">
+              <a:avLst/>
+            </a:prstGeom>
+            <a:solidFill>
+              <a:srgbClr val="FFFFFF"/>
+            </a:solidFill>
+            <a:ln w="3175">
+              <a:solidFill>
+                <a:srgbClr val="990000"/>
+              </a:solidFill>
+            </a:ln>
+          </p:spPr>
+          <p:txBody>
+            <a:bodyPr lIns="35122" tIns="35122" rIns="35122" bIns="35122" anchor="ctr"/>
+            <a:lstStyle/>
+            <a:p>
+              <a:pPr defTabSz="914437">
+                <a:spcBef>
+                  <a:spcPts val="908"/>
+                </a:spcBef>
+                <a:defRPr sz="1600"/>
+              </a:pPr>
+              <a:endParaRPr sz="1452"/>
+            </a:p>
+          </p:txBody>
+        </p:sp>
+        <p:sp>
+          <p:nvSpPr>
+            <p:cNvPr id="26" name="Rectangle">
+              <a:extLst>
+                <a:ext uri="{FF2B5EF4-FFF2-40B4-BE49-F238E27FC236}">
+                  <a16:creationId xmlns:a16="http://schemas.microsoft.com/office/drawing/2014/main" id="{C07D9BF7-3BEE-F0D7-3A2F-A4C8F168ED5B}"/>
+                </a:ext>
+              </a:extLst>
+            </p:cNvPr>
+            <p:cNvSpPr/>
+            <p:nvPr/>
+          </p:nvSpPr>
+          <p:spPr>
+            <a:xfrm>
+              <a:off x="4310543" y="2871103"/>
+              <a:ext cx="104285" cy="120766"/>
+            </a:xfrm>
+            <a:prstGeom prst="rect">
+              <a:avLst/>
+            </a:prstGeom>
+            <a:solidFill>
+              <a:srgbClr val="FFFFFF"/>
+            </a:solidFill>
+            <a:ln w="3175">
+              <a:solidFill>
+                <a:srgbClr val="990000"/>
+              </a:solidFill>
+            </a:ln>
+          </p:spPr>
+          <p:txBody>
+            <a:bodyPr lIns="35122" tIns="35122" rIns="35122" bIns="35122" anchor="ctr"/>
+            <a:lstStyle/>
+            <a:p>
+              <a:pPr defTabSz="914437">
+                <a:spcBef>
+                  <a:spcPts val="908"/>
+                </a:spcBef>
+                <a:defRPr sz="1600"/>
+              </a:pPr>
+              <a:endParaRPr sz="1452"/>
+            </a:p>
+          </p:txBody>
+        </p:sp>
+        <p:sp>
+          <p:nvSpPr>
+            <p:cNvPr id="27" name="Rectangle">
+              <a:extLst>
+                <a:ext uri="{FF2B5EF4-FFF2-40B4-BE49-F238E27FC236}">
+                  <a16:creationId xmlns:a16="http://schemas.microsoft.com/office/drawing/2014/main" id="{D4DAFFBD-5FED-C05D-A7FF-56123F75931E}"/>
+                </a:ext>
+              </a:extLst>
+            </p:cNvPr>
+            <p:cNvSpPr/>
+            <p:nvPr/>
+          </p:nvSpPr>
+          <p:spPr>
+            <a:xfrm>
+              <a:off x="4414556" y="2871103"/>
+              <a:ext cx="104286" cy="120766"/>
+            </a:xfrm>
+            <a:prstGeom prst="rect">
+              <a:avLst/>
+            </a:prstGeom>
+            <a:solidFill>
+              <a:srgbClr val="FFFFFF"/>
+            </a:solidFill>
+            <a:ln w="3175">
+              <a:solidFill>
+                <a:srgbClr val="990000"/>
+              </a:solidFill>
+            </a:ln>
+          </p:spPr>
+          <p:txBody>
+            <a:bodyPr lIns="35122" tIns="35122" rIns="35122" bIns="35122" anchor="ctr"/>
+            <a:lstStyle/>
+            <a:p>
+              <a:pPr defTabSz="914437">
+                <a:spcBef>
+                  <a:spcPts val="908"/>
+                </a:spcBef>
+                <a:defRPr sz="1600"/>
+              </a:pPr>
+              <a:endParaRPr sz="1452"/>
+            </a:p>
+          </p:txBody>
+        </p:sp>
+        <p:sp>
+          <p:nvSpPr>
+            <p:cNvPr id="28" name="Rectangle">
+              <a:extLst>
+                <a:ext uri="{FF2B5EF4-FFF2-40B4-BE49-F238E27FC236}">
+                  <a16:creationId xmlns:a16="http://schemas.microsoft.com/office/drawing/2014/main" id="{33BA6F72-584A-A120-0421-B3538324691A}"/>
+                </a:ext>
+              </a:extLst>
+            </p:cNvPr>
+            <p:cNvSpPr/>
+            <p:nvPr/>
+          </p:nvSpPr>
+          <p:spPr>
+            <a:xfrm>
+              <a:off x="4979478" y="2871103"/>
+              <a:ext cx="104285" cy="120766"/>
+            </a:xfrm>
+            <a:prstGeom prst="rect">
+              <a:avLst/>
+            </a:prstGeom>
+            <a:solidFill>
+              <a:srgbClr val="FFFFFF"/>
+            </a:solidFill>
+            <a:ln w="3175">
+              <a:solidFill>
+                <a:srgbClr val="990000"/>
+              </a:solidFill>
+            </a:ln>
+          </p:spPr>
+          <p:txBody>
+            <a:bodyPr lIns="35122" tIns="35122" rIns="35122" bIns="35122" anchor="ctr"/>
+            <a:lstStyle/>
+            <a:p>
+              <a:pPr defTabSz="914437">
+                <a:spcBef>
+                  <a:spcPts val="908"/>
+                </a:spcBef>
+                <a:defRPr sz="1600"/>
+              </a:pPr>
+              <a:endParaRPr sz="1452"/>
+            </a:p>
+          </p:txBody>
+        </p:sp>
+        <p:sp>
+          <p:nvSpPr>
+            <p:cNvPr id="29" name="Rectangle">
+              <a:extLst>
+                <a:ext uri="{FF2B5EF4-FFF2-40B4-BE49-F238E27FC236}">
+                  <a16:creationId xmlns:a16="http://schemas.microsoft.com/office/drawing/2014/main" id="{36A1B78C-C55B-30C2-6A2E-65F637CC27A7}"/>
+                </a:ext>
+              </a:extLst>
+            </p:cNvPr>
+            <p:cNvSpPr/>
+            <p:nvPr/>
+          </p:nvSpPr>
+          <p:spPr>
+            <a:xfrm>
+              <a:off x="5732976" y="2871103"/>
+              <a:ext cx="104286" cy="120766"/>
+            </a:xfrm>
+            <a:prstGeom prst="rect">
+              <a:avLst/>
+            </a:prstGeom>
+            <a:solidFill>
+              <a:srgbClr val="FFFFFF"/>
+            </a:solidFill>
+            <a:ln w="3175">
+              <a:solidFill>
+                <a:srgbClr val="990000"/>
+              </a:solidFill>
+            </a:ln>
+          </p:spPr>
+          <p:txBody>
+            <a:bodyPr lIns="35122" tIns="35122" rIns="35122" bIns="35122" anchor="ctr"/>
+            <a:lstStyle/>
+            <a:p>
+              <a:pPr defTabSz="914437">
+                <a:spcBef>
+                  <a:spcPts val="908"/>
+                </a:spcBef>
+                <a:defRPr sz="1600"/>
+              </a:pPr>
+              <a:endParaRPr sz="1452"/>
+            </a:p>
+          </p:txBody>
+        </p:sp>
+        <p:sp>
+          <p:nvSpPr>
+            <p:cNvPr id="30" name="Rectangle">
+              <a:extLst>
+                <a:ext uri="{FF2B5EF4-FFF2-40B4-BE49-F238E27FC236}">
+                  <a16:creationId xmlns:a16="http://schemas.microsoft.com/office/drawing/2014/main" id="{838D9377-DDA8-1D82-3DF5-AFEBC45ABE36}"/>
+                </a:ext>
+              </a:extLst>
+            </p:cNvPr>
+            <p:cNvSpPr/>
+            <p:nvPr/>
+          </p:nvSpPr>
+          <p:spPr>
+            <a:xfrm>
+              <a:off x="5836722" y="2871103"/>
+              <a:ext cx="104285" cy="120766"/>
+            </a:xfrm>
+            <a:prstGeom prst="rect">
+              <a:avLst/>
+            </a:prstGeom>
+            <a:solidFill>
+              <a:srgbClr val="FFFFFF"/>
+            </a:solidFill>
+            <a:ln w="3175">
+              <a:solidFill>
+                <a:srgbClr val="990000"/>
+              </a:solidFill>
+            </a:ln>
+          </p:spPr>
+          <p:txBody>
+            <a:bodyPr lIns="35122" tIns="35122" rIns="35122" bIns="35122" anchor="ctr"/>
+            <a:lstStyle/>
+            <a:p>
+              <a:pPr defTabSz="914437">
+                <a:spcBef>
+                  <a:spcPts val="908"/>
+                </a:spcBef>
+                <a:defRPr sz="1600"/>
+              </a:pPr>
+              <a:endParaRPr sz="1452"/>
+            </a:p>
+          </p:txBody>
+        </p:sp>
+        <p:sp>
+          <p:nvSpPr>
+            <p:cNvPr id="31" name="…">
+              <a:extLst>
+                <a:ext uri="{FF2B5EF4-FFF2-40B4-BE49-F238E27FC236}">
+                  <a16:creationId xmlns:a16="http://schemas.microsoft.com/office/drawing/2014/main" id="{2BA33666-F042-837E-0622-B08C190B590A}"/>
+                </a:ext>
+              </a:extLst>
+            </p:cNvPr>
+            <p:cNvSpPr txBox="1"/>
+            <p:nvPr/>
+          </p:nvSpPr>
+          <p:spPr>
+            <a:xfrm>
+              <a:off x="5327454" y="2806803"/>
+              <a:ext cx="132922" cy="195566"/>
+            </a:xfrm>
+            <a:prstGeom prst="rect">
+              <a:avLst/>
+            </a:prstGeom>
+            <a:ln w="12700">
+              <a:miter lim="400000"/>
+            </a:ln>
+            <a:extLst>
+              <a:ext uri="{C572A759-6A51-4108-AA02-DFA0A04FC94B}">
+                <ma14:wrappingTextBoxFlag xmlns="" xmlns:m="http://schemas.openxmlformats.org/officeDocument/2006/math" xmlns:a14="http://schemas.microsoft.com/office/drawing/2010/main" xmlns:ma14="http://schemas.microsoft.com/office/mac/drawingml/2011/main" val="1"/>
+              </a:ext>
+            </a:extLst>
+          </p:spPr>
+          <p:txBody>
+            <a:bodyPr wrap="none" lIns="0" tIns="0" rIns="0" bIns="0">
+              <a:spAutoFit/>
+            </a:bodyPr>
+            <a:lstStyle>
+              <a:lvl1pPr defTabSz="1007533">
+                <a:spcBef>
+                  <a:spcPts val="900"/>
+                </a:spcBef>
+                <a:defRPr sz="1400" spc="-1"/>
+              </a:lvl1pPr>
+            </a:lstStyle>
+            <a:p>
+              <a:r>
+                <a:rPr sz="1271"/>
+                <a:t>…</a:t>
+              </a:r>
+            </a:p>
+          </p:txBody>
+        </p:sp>
+        <p:sp>
+          <p:nvSpPr>
+            <p:cNvPr id="32" name="…">
+              <a:extLst>
+                <a:ext uri="{FF2B5EF4-FFF2-40B4-BE49-F238E27FC236}">
+                  <a16:creationId xmlns:a16="http://schemas.microsoft.com/office/drawing/2014/main" id="{A51019BF-CB54-4F93-1CF0-C8E70A37E430}"/>
+                </a:ext>
+              </a:extLst>
+            </p:cNvPr>
+            <p:cNvSpPr txBox="1"/>
+            <p:nvPr/>
+          </p:nvSpPr>
+          <p:spPr>
+            <a:xfrm>
+              <a:off x="4665003" y="2806803"/>
+              <a:ext cx="132922" cy="195566"/>
+            </a:xfrm>
+            <a:prstGeom prst="rect">
+              <a:avLst/>
+            </a:prstGeom>
+            <a:ln w="12700">
+              <a:miter lim="400000"/>
+            </a:ln>
+            <a:extLst>
+              <a:ext uri="{C572A759-6A51-4108-AA02-DFA0A04FC94B}">
+                <ma14:wrappingTextBoxFlag xmlns="" xmlns:m="http://schemas.openxmlformats.org/officeDocument/2006/math" xmlns:a14="http://schemas.microsoft.com/office/drawing/2010/main" xmlns:ma14="http://schemas.microsoft.com/office/mac/drawingml/2011/main" val="1"/>
+              </a:ext>
+            </a:extLst>
+          </p:spPr>
+          <p:txBody>
+            <a:bodyPr wrap="none" lIns="0" tIns="0" rIns="0" bIns="0">
+              <a:spAutoFit/>
+            </a:bodyPr>
+            <a:lstStyle>
+              <a:lvl1pPr defTabSz="1007533">
+                <a:spcBef>
+                  <a:spcPts val="900"/>
+                </a:spcBef>
+                <a:defRPr sz="1400" spc="-1"/>
+              </a:lvl1pPr>
+            </a:lstStyle>
+            <a:p>
+              <a:r>
+                <a:rPr sz="1271"/>
+                <a:t>…</a:t>
+              </a:r>
+            </a:p>
+          </p:txBody>
+        </p:sp>
+        <p:sp>
+          <p:nvSpPr>
+            <p:cNvPr id="33" name="Connection Line">
+              <a:extLst>
+                <a:ext uri="{FF2B5EF4-FFF2-40B4-BE49-F238E27FC236}">
+                  <a16:creationId xmlns:a16="http://schemas.microsoft.com/office/drawing/2014/main" id="{5073BAD0-C43A-7691-F446-1B52E5DF5CB2}"/>
+                </a:ext>
+              </a:extLst>
+            </p:cNvPr>
+            <p:cNvSpPr/>
+            <p:nvPr/>
+          </p:nvSpPr>
+          <p:spPr>
+            <a:xfrm>
+              <a:off x="5081061" y="3109662"/>
+              <a:ext cx="1592911" cy="235590"/>
+            </a:xfrm>
+            <a:custGeom>
+              <a:avLst/>
+              <a:gdLst/>
+              <a:ahLst/>
+              <a:cxnLst>
+                <a:cxn ang="0">
+                  <a:pos x="wd2" y="hd2"/>
+                </a:cxn>
+                <a:cxn ang="5400000">
+                  <a:pos x="wd2" y="hd2"/>
+                </a:cxn>
+                <a:cxn ang="10800000">
+                  <a:pos x="wd2" y="hd2"/>
+                </a:cxn>
+                <a:cxn ang="16200000">
+                  <a:pos x="wd2" y="hd2"/>
+                </a:cxn>
+              </a:cxnLst>
+              <a:rect l="0" t="0" r="r" b="b"/>
+              <a:pathLst>
+                <a:path w="21600" h="16237" extrusionOk="0">
+                  <a:moveTo>
+                    <a:pt x="21600" y="2963"/>
+                  </a:moveTo>
+                  <a:cubicBezTo>
+                    <a:pt x="13103" y="21600"/>
+                    <a:pt x="5903" y="20612"/>
+                    <a:pt x="0" y="0"/>
+                  </a:cubicBezTo>
+                </a:path>
+              </a:pathLst>
+            </a:custGeom>
+            <a:ln w="3175">
+              <a:solidFill>
+                <a:srgbClr val="990000"/>
+              </a:solidFill>
+              <a:headEnd type="triangle"/>
+            </a:ln>
+            <a:effectLst>
+              <a:outerShdw rotWithShape="0">
+                <a:srgbClr val="000000">
+                  <a:alpha val="38000"/>
+                </a:srgbClr>
+              </a:outerShdw>
+            </a:effectLst>
+          </p:spPr>
+          <p:txBody>
+            <a:bodyPr lIns="35122" tIns="35122" rIns="35122" bIns="35122" anchor="ctr"/>
+            <a:lstStyle/>
+            <a:p>
+              <a:pPr defTabSz="914437">
+                <a:spcBef>
+                  <a:spcPts val="908"/>
+                </a:spcBef>
+                <a:defRPr sz="1600"/>
+              </a:pPr>
+              <a:endParaRPr sz="1452"/>
+            </a:p>
+          </p:txBody>
+        </p:sp>
+        <p:sp>
+          <p:nvSpPr>
+            <p:cNvPr id="34" name="In bin i, N events each carrying a fractional intensity pj so that">
+              <a:extLst>
+                <a:ext uri="{FF2B5EF4-FFF2-40B4-BE49-F238E27FC236}">
+                  <a16:creationId xmlns:a16="http://schemas.microsoft.com/office/drawing/2014/main" id="{33B747D9-1B26-1389-9922-C24FEAF691C7}"/>
+                </a:ext>
+              </a:extLst>
+            </p:cNvPr>
+            <p:cNvSpPr txBox="1"/>
+            <p:nvPr/>
+          </p:nvSpPr>
+          <p:spPr>
+            <a:xfrm>
+              <a:off x="6874707" y="2781137"/>
+              <a:ext cx="1678014" cy="1173398"/>
+            </a:xfrm>
+            <a:prstGeom prst="rect">
+              <a:avLst/>
+            </a:prstGeom>
+            <a:ln w="12700">
+              <a:miter lim="400000"/>
+            </a:ln>
+            <a:extLst>
+              <a:ext uri="{C572A759-6A51-4108-AA02-DFA0A04FC94B}">
+                <ma14:wrappingTextBoxFlag xmlns="" xmlns:m="http://schemas.openxmlformats.org/officeDocument/2006/math" xmlns:a14="http://schemas.microsoft.com/office/drawing/2010/main" xmlns:ma14="http://schemas.microsoft.com/office/mac/drawingml/2011/main" val="1"/>
+              </a:ext>
+            </a:extLst>
+          </p:spPr>
+          <p:txBody>
+            <a:bodyPr lIns="0" tIns="0" rIns="0" bIns="0">
+              <a:spAutoFit/>
+            </a:bodyPr>
+            <a:lstStyle/>
+            <a:p>
+              <a:pPr defTabSz="914437">
+                <a:spcBef>
+                  <a:spcPts val="817"/>
+                </a:spcBef>
+                <a:defRPr sz="1400" spc="-1">
+                  <a:latin typeface="Verdana"/>
+                  <a:ea typeface="Verdana"/>
+                  <a:cs typeface="Verdana"/>
+                  <a:sym typeface="Verdana"/>
+                </a:defRPr>
+              </a:pPr>
+              <a:r>
+                <a:rPr sz="1271" dirty="0"/>
+                <a:t>In bin </a:t>
+              </a:r>
+              <a:r>
+                <a:rPr sz="1271" i="1" dirty="0" err="1"/>
+                <a:t>i</a:t>
+              </a:r>
+              <a:r>
+                <a:rPr sz="1271" i="1" dirty="0"/>
+                <a:t>,</a:t>
+              </a:r>
+              <a:r>
+                <a:rPr sz="1271" dirty="0"/>
+                <a:t> </a:t>
+              </a:r>
+              <a:r>
+                <a:rPr sz="1271" b="1" i="1" dirty="0"/>
+                <a:t>N</a:t>
+              </a:r>
+              <a:r>
+                <a:rPr sz="1271" i="1" dirty="0"/>
+                <a:t> </a:t>
+              </a:r>
+              <a:r>
+                <a:rPr sz="1271" dirty="0"/>
+                <a:t>events each carrying a fractional intensity </a:t>
+              </a:r>
+              <a:r>
+                <a:rPr sz="1271" i="1" dirty="0" err="1"/>
+                <a:t>p</a:t>
+              </a:r>
+              <a:r>
+                <a:rPr sz="1271" i="1" baseline="-5000" dirty="0" err="1"/>
+                <a:t>j</a:t>
+              </a:r>
+              <a:r>
+                <a:rPr sz="1271" i="1" dirty="0"/>
+                <a:t> </a:t>
+              </a:r>
+              <a:r>
+                <a:rPr sz="1271" dirty="0"/>
+                <a:t>so that</a:t>
+              </a:r>
+              <a:br>
+                <a:rPr sz="1271" dirty="0"/>
+              </a:br>
+              <a:br>
+                <a:rPr sz="1271" dirty="0"/>
+              </a:br>
+              <a:endParaRPr sz="1271" dirty="0"/>
+            </a:p>
+          </p:txBody>
+        </p:sp>
+        <p:sp>
+          <p:nvSpPr>
+            <p:cNvPr id="35" name="1">
+              <a:extLst>
+                <a:ext uri="{FF2B5EF4-FFF2-40B4-BE49-F238E27FC236}">
+                  <a16:creationId xmlns:a16="http://schemas.microsoft.com/office/drawing/2014/main" id="{98FF47E0-247E-B90C-8A33-21FB85C93CA5}"/>
+                </a:ext>
+              </a:extLst>
+            </p:cNvPr>
+            <p:cNvSpPr txBox="1"/>
+            <p:nvPr/>
+          </p:nvSpPr>
+          <p:spPr>
+            <a:xfrm>
+              <a:off x="4209769" y="3001594"/>
+              <a:ext cx="86434" cy="195566"/>
+            </a:xfrm>
+            <a:prstGeom prst="rect">
+              <a:avLst/>
+            </a:prstGeom>
+            <a:ln w="12700">
+              <a:miter lim="400000"/>
+            </a:ln>
+            <a:extLst>
+              <a:ext uri="{C572A759-6A51-4108-AA02-DFA0A04FC94B}">
+                <ma14:wrappingTextBoxFlag xmlns="" xmlns:m="http://schemas.openxmlformats.org/officeDocument/2006/math" xmlns:a14="http://schemas.microsoft.com/office/drawing/2010/main" xmlns:ma14="http://schemas.microsoft.com/office/mac/drawingml/2011/main" val="1"/>
+              </a:ext>
+            </a:extLst>
+          </p:spPr>
+          <p:txBody>
+            <a:bodyPr wrap="none" lIns="0" tIns="0" rIns="0" bIns="0">
+              <a:spAutoFit/>
+            </a:bodyPr>
+            <a:lstStyle>
+              <a:lvl1pPr defTabSz="1007533">
+                <a:spcBef>
+                  <a:spcPts val="900"/>
+                </a:spcBef>
+                <a:defRPr sz="1400" spc="-1"/>
+              </a:lvl1pPr>
+            </a:lstStyle>
+            <a:p>
+              <a:r>
+                <a:rPr sz="1271"/>
+                <a:t>1</a:t>
+              </a:r>
+            </a:p>
+          </p:txBody>
+        </p:sp>
+        <p:sp>
+          <p:nvSpPr>
+            <p:cNvPr id="36" name="2">
+              <a:extLst>
+                <a:ext uri="{FF2B5EF4-FFF2-40B4-BE49-F238E27FC236}">
+                  <a16:creationId xmlns:a16="http://schemas.microsoft.com/office/drawing/2014/main" id="{995A5167-8E86-46D9-5B77-43FE7E7E91FD}"/>
+                </a:ext>
+              </a:extLst>
+            </p:cNvPr>
+            <p:cNvSpPr txBox="1"/>
+            <p:nvPr/>
+          </p:nvSpPr>
+          <p:spPr>
+            <a:xfrm>
+              <a:off x="4313784" y="3001594"/>
+              <a:ext cx="86434" cy="195566"/>
+            </a:xfrm>
+            <a:prstGeom prst="rect">
+              <a:avLst/>
+            </a:prstGeom>
+            <a:ln w="12700">
+              <a:miter lim="400000"/>
+            </a:ln>
+            <a:extLst>
+              <a:ext uri="{C572A759-6A51-4108-AA02-DFA0A04FC94B}">
+                <ma14:wrappingTextBoxFlag xmlns="" xmlns:m="http://schemas.openxmlformats.org/officeDocument/2006/math" xmlns:a14="http://schemas.microsoft.com/office/drawing/2010/main" xmlns:ma14="http://schemas.microsoft.com/office/mac/drawingml/2011/main" val="1"/>
+              </a:ext>
+            </a:extLst>
+          </p:spPr>
+          <p:txBody>
+            <a:bodyPr wrap="none" lIns="0" tIns="0" rIns="0" bIns="0">
+              <a:spAutoFit/>
+            </a:bodyPr>
+            <a:lstStyle>
+              <a:lvl1pPr defTabSz="1007533">
+                <a:spcBef>
+                  <a:spcPts val="900"/>
+                </a:spcBef>
+                <a:defRPr sz="1400" spc="-1"/>
+              </a:lvl1pPr>
+            </a:lstStyle>
+            <a:p>
+              <a:r>
+                <a:rPr sz="1271"/>
+                <a:t>2</a:t>
+              </a:r>
+            </a:p>
+          </p:txBody>
+        </p:sp>
+        <p:sp>
+          <p:nvSpPr>
+            <p:cNvPr id="37" name="i">
+              <a:extLst>
+                <a:ext uri="{FF2B5EF4-FFF2-40B4-BE49-F238E27FC236}">
+                  <a16:creationId xmlns:a16="http://schemas.microsoft.com/office/drawing/2014/main" id="{2DE65304-FC24-FD87-2D12-C34F8B51E6C1}"/>
+                </a:ext>
+              </a:extLst>
+            </p:cNvPr>
+            <p:cNvSpPr txBox="1"/>
+            <p:nvPr/>
+          </p:nvSpPr>
+          <p:spPr>
+            <a:xfrm>
+              <a:off x="5017841" y="3001594"/>
+              <a:ext cx="38344" cy="195566"/>
+            </a:xfrm>
+            <a:prstGeom prst="rect">
+              <a:avLst/>
+            </a:prstGeom>
+            <a:ln w="12700">
+              <a:miter lim="400000"/>
+            </a:ln>
+            <a:extLst>
+              <a:ext uri="{C572A759-6A51-4108-AA02-DFA0A04FC94B}">
+                <ma14:wrappingTextBoxFlag xmlns="" xmlns:m="http://schemas.openxmlformats.org/officeDocument/2006/math" xmlns:a14="http://schemas.microsoft.com/office/drawing/2010/main" xmlns:ma14="http://schemas.microsoft.com/office/mac/drawingml/2011/main" val="1"/>
+              </a:ext>
+            </a:extLst>
+          </p:spPr>
+          <p:txBody>
+            <a:bodyPr wrap="none" lIns="0" tIns="0" rIns="0" bIns="0">
+              <a:spAutoFit/>
+            </a:bodyPr>
+            <a:lstStyle>
+              <a:lvl1pPr defTabSz="1007533">
+                <a:spcBef>
+                  <a:spcPts val="900"/>
+                </a:spcBef>
+                <a:defRPr sz="1400" spc="-1"/>
+              </a:lvl1pPr>
+            </a:lstStyle>
+            <a:p>
+              <a:r>
+                <a:rPr sz="1271"/>
+                <a:t>i</a:t>
+              </a:r>
+            </a:p>
+          </p:txBody>
+        </p:sp>
+        <p:sp>
+          <p:nvSpPr>
+            <p:cNvPr id="38" name="k">
+              <a:extLst>
+                <a:ext uri="{FF2B5EF4-FFF2-40B4-BE49-F238E27FC236}">
+                  <a16:creationId xmlns:a16="http://schemas.microsoft.com/office/drawing/2014/main" id="{19482F18-45E2-A47A-8E88-EEEB3B357F89}"/>
+                </a:ext>
+              </a:extLst>
+            </p:cNvPr>
+            <p:cNvSpPr txBox="1"/>
+            <p:nvPr/>
+          </p:nvSpPr>
+          <p:spPr>
+            <a:xfrm>
+              <a:off x="5849690" y="3001594"/>
+              <a:ext cx="78419" cy="195566"/>
+            </a:xfrm>
+            <a:prstGeom prst="rect">
+              <a:avLst/>
+            </a:prstGeom>
+            <a:ln w="12700">
+              <a:miter lim="400000"/>
+            </a:ln>
+            <a:extLst>
+              <a:ext uri="{C572A759-6A51-4108-AA02-DFA0A04FC94B}">
+                <ma14:wrappingTextBoxFlag xmlns="" xmlns:m="http://schemas.openxmlformats.org/officeDocument/2006/math" xmlns:a14="http://schemas.microsoft.com/office/drawing/2010/main" xmlns:ma14="http://schemas.microsoft.com/office/mac/drawingml/2011/main" val="1"/>
+              </a:ext>
+            </a:extLst>
+          </p:spPr>
+          <p:txBody>
+            <a:bodyPr wrap="none" lIns="0" tIns="0" rIns="0" bIns="0">
+              <a:spAutoFit/>
+            </a:bodyPr>
+            <a:lstStyle>
+              <a:lvl1pPr defTabSz="1007533">
+                <a:spcBef>
+                  <a:spcPts val="900"/>
+                </a:spcBef>
+                <a:defRPr sz="1400" spc="-1"/>
+              </a:lvl1pPr>
+            </a:lstStyle>
+            <a:p>
+              <a:r>
+                <a:rPr sz="1271" dirty="0"/>
+                <a:t>k</a:t>
+              </a:r>
+            </a:p>
+          </p:txBody>
+        </p:sp>
+        <p:sp>
+          <p:nvSpPr>
+            <p:cNvPr id="39" name="3">
+              <a:extLst>
+                <a:ext uri="{FF2B5EF4-FFF2-40B4-BE49-F238E27FC236}">
+                  <a16:creationId xmlns:a16="http://schemas.microsoft.com/office/drawing/2014/main" id="{86AB94C4-26C8-17A5-9C87-8D402A90898B}"/>
+                </a:ext>
+              </a:extLst>
+            </p:cNvPr>
+            <p:cNvSpPr txBox="1"/>
+            <p:nvPr/>
+          </p:nvSpPr>
+          <p:spPr>
+            <a:xfrm>
+              <a:off x="4424283" y="3001594"/>
+              <a:ext cx="86434" cy="195566"/>
+            </a:xfrm>
+            <a:prstGeom prst="rect">
+              <a:avLst/>
+            </a:prstGeom>
+            <a:ln w="12700">
+              <a:miter lim="400000"/>
+            </a:ln>
+            <a:extLst>
+              <a:ext uri="{C572A759-6A51-4108-AA02-DFA0A04FC94B}">
+                <ma14:wrappingTextBoxFlag xmlns="" xmlns:m="http://schemas.openxmlformats.org/officeDocument/2006/math" xmlns:a14="http://schemas.microsoft.com/office/drawing/2010/main" xmlns:ma14="http://schemas.microsoft.com/office/mac/drawingml/2011/main" val="1"/>
+              </a:ext>
+            </a:extLst>
+          </p:spPr>
+          <p:txBody>
+            <a:bodyPr wrap="none" lIns="0" tIns="0" rIns="0" bIns="0">
+              <a:spAutoFit/>
+            </a:bodyPr>
+            <a:lstStyle>
+              <a:lvl1pPr defTabSz="1007533">
+                <a:spcBef>
+                  <a:spcPts val="900"/>
+                </a:spcBef>
+                <a:defRPr sz="1400" spc="-1"/>
+              </a:lvl1pPr>
+            </a:lstStyle>
+            <a:p>
+              <a:r>
+                <a:rPr sz="1271"/>
+                <a:t>3</a:t>
+              </a:r>
+            </a:p>
+          </p:txBody>
+        </p:sp>
+        <p:pic>
+          <p:nvPicPr>
+            <p:cNvPr id="40" name="Image" descr="Image">
+              <a:extLst>
+                <a:ext uri="{FF2B5EF4-FFF2-40B4-BE49-F238E27FC236}">
+                  <a16:creationId xmlns:a16="http://schemas.microsoft.com/office/drawing/2014/main" id="{5E164C5F-FE87-78C4-A234-FB90815753B4}"/>
+                </a:ext>
+              </a:extLst>
+            </p:cNvPr>
+            <p:cNvPicPr>
+              <a:picLocks noChangeAspect="1"/>
+            </p:cNvPicPr>
+            <p:nvPr/>
+          </p:nvPicPr>
+          <p:blipFill>
+            <a:blip r:embed="rId4"/>
+            <a:stretch>
+              <a:fillRect/>
+            </a:stretch>
+          </p:blipFill>
+          <p:spPr>
+            <a:xfrm>
+              <a:off x="4540725" y="3414680"/>
+              <a:ext cx="765928" cy="390394"/>
+            </a:xfrm>
+            <a:prstGeom prst="rect">
+              <a:avLst/>
+            </a:prstGeom>
+            <a:ln w="12700">
+              <a:miter lim="400000"/>
+            </a:ln>
+          </p:spPr>
+        </p:pic>
+      </p:grpSp>
     </p:spTree>
   </p:cSld>
   <p:clrMapOvr>
@@ -6720,6 +7852,905 @@
 
 <file path=ppt/slides/slide16.xml><?xml version="1.0" encoding="utf-8"?>
 <p:sld xmlns:a="http://schemas.openxmlformats.org/drawingml/2006/main" xmlns:r="http://schemas.openxmlformats.org/officeDocument/2006/relationships" xmlns:p="http://schemas.openxmlformats.org/presentationml/2006/main">
+  <p:cSld>
+    <p:spTree>
+      <p:nvGrpSpPr>
+        <p:cNvPr id="1" name="">
+          <a:extLst>
+            <a:ext uri="{FF2B5EF4-FFF2-40B4-BE49-F238E27FC236}">
+              <a16:creationId xmlns:a16="http://schemas.microsoft.com/office/drawing/2014/main" id="{5AAE0AE3-13F3-312F-2581-DB55B26FADEE}"/>
+            </a:ext>
+          </a:extLst>
+        </p:cNvPr>
+        <p:cNvGrpSpPr/>
+        <p:nvPr/>
+      </p:nvGrpSpPr>
+      <p:grpSpPr>
+        <a:xfrm>
+          <a:off x="0" y="0"/>
+          <a:ext cx="0" cy="0"/>
+          <a:chOff x="0" y="0"/>
+          <a:chExt cx="0" cy="0"/>
+        </a:xfrm>
+      </p:grpSpPr>
+      <p:pic>
+        <p:nvPicPr>
+          <p:cNvPr id="2" name="Image 0" descr="/home/claude/work/assets/panraid_logo.png">
+            <a:extLst>
+              <a:ext uri="{FF2B5EF4-FFF2-40B4-BE49-F238E27FC236}">
+                <a16:creationId xmlns:a16="http://schemas.microsoft.com/office/drawing/2014/main" id="{855E20A7-2BB8-3FC1-B4D6-374958283B99}"/>
+              </a:ext>
+            </a:extLst>
+          </p:cNvPr>
+          <p:cNvPicPr>
+            <a:picLocks noChangeAspect="1"/>
+          </p:cNvPicPr>
+          <p:nvPr/>
+        </p:nvPicPr>
+        <p:blipFill>
+          <a:blip r:embed="rId3"/>
+          <a:stretch>
+            <a:fillRect/>
+          </a:stretch>
+        </p:blipFill>
+        <p:spPr>
+          <a:xfrm>
+            <a:off x="10376611" y="355702"/>
+            <a:ext cx="1270102" cy="651510"/>
+          </a:xfrm>
+          <a:prstGeom prst="rect">
+            <a:avLst/>
+          </a:prstGeom>
+        </p:spPr>
+      </p:pic>
+      <p:sp>
+        <p:nvSpPr>
+          <p:cNvPr id="3" name="Text 0">
+            <a:extLst>
+              <a:ext uri="{FF2B5EF4-FFF2-40B4-BE49-F238E27FC236}">
+                <a16:creationId xmlns:a16="http://schemas.microsoft.com/office/drawing/2014/main" id="{F34AD18B-4B16-D9F9-E568-84BC1DAAED84}"/>
+              </a:ext>
+            </a:extLst>
+          </p:cNvPr>
+          <p:cNvSpPr/>
+          <p:nvPr/>
+        </p:nvSpPr>
+        <p:spPr>
+          <a:xfrm>
+            <a:off x="548640" y="384048"/>
+            <a:ext cx="8686800" cy="292608"/>
+          </a:xfrm>
+          <a:prstGeom prst="rect">
+            <a:avLst/>
+          </a:prstGeom>
+          <a:noFill/>
+          <a:ln/>
+        </p:spPr>
+        <p:txBody>
+          <a:bodyPr wrap="square" rtlCol="0" anchor="ctr"/>
+          <a:lstStyle/>
+          <a:p>
+            <a:pPr marL="0" indent="0">
+              <a:buNone/>
+            </a:pPr>
+            <a:r>
+              <a:rPr lang="en-US" sz="1200" b="1" kern="0" spc="200" dirty="0">
+                <a:solidFill>
+                  <a:srgbClr val="1C7293"/>
+                </a:solidFill>
+                <a:latin typeface="Calibri" pitchFamily="34" charset="0"/>
+                <a:ea typeface="Calibri" pitchFamily="34" charset="-122"/>
+                <a:cs typeface="Calibri" pitchFamily="34" charset="-120"/>
+              </a:rPr>
+              <a:t>MONITOR OUTPUTS</a:t>
+            </a:r>
+            <a:endParaRPr lang="en-US" sz="1200" dirty="0"/>
+          </a:p>
+        </p:txBody>
+      </p:sp>
+      <p:sp>
+        <p:nvSpPr>
+          <p:cNvPr id="4" name="Text 1">
+            <a:extLst>
+              <a:ext uri="{FF2B5EF4-FFF2-40B4-BE49-F238E27FC236}">
+                <a16:creationId xmlns:a16="http://schemas.microsoft.com/office/drawing/2014/main" id="{CD94F5D7-39D6-CBA0-546B-E54334DE6CA2}"/>
+              </a:ext>
+            </a:extLst>
+          </p:cNvPr>
+          <p:cNvSpPr/>
+          <p:nvPr/>
+        </p:nvSpPr>
+        <p:spPr>
+          <a:xfrm>
+            <a:off x="548640" y="658368"/>
+            <a:ext cx="9601200" cy="822960"/>
+          </a:xfrm>
+          <a:prstGeom prst="rect">
+            <a:avLst/>
+          </a:prstGeom>
+          <a:noFill/>
+          <a:ln/>
+        </p:spPr>
+        <p:txBody>
+          <a:bodyPr wrap="square" rtlCol="0" anchor="ctr"/>
+          <a:lstStyle/>
+          <a:p>
+            <a:pPr marL="0" indent="0" algn="l">
+              <a:buNone/>
+            </a:pPr>
+            <a:r>
+              <a:rPr lang="en-US" sz="3000" b="1" dirty="0">
+                <a:solidFill>
+                  <a:srgbClr val="20242B"/>
+                </a:solidFill>
+                <a:latin typeface="Cambria" pitchFamily="34" charset="0"/>
+                <a:ea typeface="Cambria" pitchFamily="34" charset="-122"/>
+                <a:cs typeface="Cambria" pitchFamily="34" charset="-120"/>
+              </a:rPr>
+              <a:t>1D and 2D example output (by default in Ascii)</a:t>
+            </a:r>
+            <a:endParaRPr lang="en-US" sz="3000" dirty="0"/>
+          </a:p>
+        </p:txBody>
+      </p:sp>
+      <p:sp>
+        <p:nvSpPr>
+          <p:cNvPr id="12" name="Text 9">
+            <a:extLst>
+              <a:ext uri="{FF2B5EF4-FFF2-40B4-BE49-F238E27FC236}">
+                <a16:creationId xmlns:a16="http://schemas.microsoft.com/office/drawing/2014/main" id="{416926AF-EA84-181E-51B8-5B999ACDBC3B}"/>
+              </a:ext>
+            </a:extLst>
+          </p:cNvPr>
+          <p:cNvSpPr/>
+          <p:nvPr/>
+        </p:nvSpPr>
+        <p:spPr>
+          <a:xfrm>
+            <a:off x="548640" y="6446520"/>
+            <a:ext cx="6400800" cy="274320"/>
+          </a:xfrm>
+          <a:prstGeom prst="rect">
+            <a:avLst/>
+          </a:prstGeom>
+          <a:noFill/>
+          <a:ln/>
+        </p:spPr>
+        <p:txBody>
+          <a:bodyPr wrap="square" rtlCol="0" anchor="ctr"/>
+          <a:lstStyle/>
+          <a:p>
+            <a:pPr marL="0" indent="0" algn="l">
+              <a:buNone/>
+            </a:pPr>
+            <a:r>
+              <a:rPr lang="en-US" sz="900" dirty="0">
+                <a:solidFill>
+                  <a:srgbClr val="6E7580"/>
+                </a:solidFill>
+                <a:latin typeface="Calibri" pitchFamily="34" charset="0"/>
+                <a:ea typeface="Calibri" pitchFamily="34" charset="-122"/>
+                <a:cs typeface="Calibri" pitchFamily="34" charset="-120"/>
+              </a:rPr>
+              <a:t>McStas &amp; McXtrace  ·  Sources &amp; Monitors</a:t>
+            </a:r>
+            <a:endParaRPr lang="en-US" sz="900" dirty="0"/>
+          </a:p>
+        </p:txBody>
+      </p:sp>
+      <p:sp>
+        <p:nvSpPr>
+          <p:cNvPr id="13" name="Text 10">
+            <a:extLst>
+              <a:ext uri="{FF2B5EF4-FFF2-40B4-BE49-F238E27FC236}">
+                <a16:creationId xmlns:a16="http://schemas.microsoft.com/office/drawing/2014/main" id="{C68833CD-26B3-5C22-93C1-8A77CE5A1B78}"/>
+              </a:ext>
+            </a:extLst>
+          </p:cNvPr>
+          <p:cNvSpPr/>
+          <p:nvPr/>
+        </p:nvSpPr>
+        <p:spPr>
+          <a:xfrm>
+            <a:off x="11185855" y="6446520"/>
+            <a:ext cx="457200" cy="274320"/>
+          </a:xfrm>
+          <a:prstGeom prst="rect">
+            <a:avLst/>
+          </a:prstGeom>
+          <a:noFill/>
+          <a:ln/>
+        </p:spPr>
+        <p:txBody>
+          <a:bodyPr wrap="square" rtlCol="0" anchor="ctr"/>
+          <a:lstStyle/>
+          <a:p>
+            <a:pPr marL="0" indent="0" algn="r">
+              <a:buNone/>
+            </a:pPr>
+            <a:r>
+              <a:rPr lang="en-US" sz="900" dirty="0">
+                <a:solidFill>
+                  <a:srgbClr val="6E7580"/>
+                </a:solidFill>
+                <a:latin typeface="Calibri" pitchFamily="34" charset="0"/>
+                <a:ea typeface="Calibri" pitchFamily="34" charset="-122"/>
+                <a:cs typeface="Calibri" pitchFamily="34" charset="-120"/>
+              </a:rPr>
+              <a:t>15</a:t>
+            </a:r>
+            <a:endParaRPr lang="en-US" sz="900" dirty="0"/>
+          </a:p>
+        </p:txBody>
+      </p:sp>
+      <p:pic>
+        <p:nvPicPr>
+          <p:cNvPr id="15" name="Picture 14">
+            <a:extLst>
+              <a:ext uri="{FF2B5EF4-FFF2-40B4-BE49-F238E27FC236}">
+                <a16:creationId xmlns:a16="http://schemas.microsoft.com/office/drawing/2014/main" id="{1050B78F-9925-D859-6B11-726D084D4A47}"/>
+              </a:ext>
+            </a:extLst>
+          </p:cNvPr>
+          <p:cNvPicPr>
+            <a:picLocks noChangeAspect="1"/>
+          </p:cNvPicPr>
+          <p:nvPr/>
+        </p:nvPicPr>
+        <p:blipFill>
+          <a:blip r:embed="rId4"/>
+          <a:stretch>
+            <a:fillRect/>
+          </a:stretch>
+        </p:blipFill>
+        <p:spPr>
+          <a:xfrm>
+            <a:off x="0" y="1362456"/>
+            <a:ext cx="6136301" cy="3742943"/>
+          </a:xfrm>
+          <a:prstGeom prst="rect">
+            <a:avLst/>
+          </a:prstGeom>
+        </p:spPr>
+      </p:pic>
+      <p:grpSp>
+        <p:nvGrpSpPr>
+          <p:cNvPr id="16" name="Group 15">
+            <a:extLst>
+              <a:ext uri="{FF2B5EF4-FFF2-40B4-BE49-F238E27FC236}">
+                <a16:creationId xmlns:a16="http://schemas.microsoft.com/office/drawing/2014/main" id="{BEA2FBC6-F84D-9863-CF5D-799E07B87F38}"/>
+              </a:ext>
+            </a:extLst>
+          </p:cNvPr>
+          <p:cNvGrpSpPr/>
+          <p:nvPr/>
+        </p:nvGrpSpPr>
+        <p:grpSpPr>
+          <a:xfrm>
+            <a:off x="6136301" y="1190804"/>
+            <a:ext cx="6055700" cy="3914596"/>
+            <a:chOff x="1784306" y="1259741"/>
+            <a:chExt cx="8852828" cy="5257332"/>
+          </a:xfrm>
+        </p:grpSpPr>
+        <p:pic>
+          <p:nvPicPr>
+            <p:cNvPr id="17" name="Picture 16">
+              <a:extLst>
+                <a:ext uri="{FF2B5EF4-FFF2-40B4-BE49-F238E27FC236}">
+                  <a16:creationId xmlns:a16="http://schemas.microsoft.com/office/drawing/2014/main" id="{A16460E1-B1FE-4DC3-61FB-37F27330208C}"/>
+                </a:ext>
+              </a:extLst>
+            </p:cNvPr>
+            <p:cNvPicPr>
+              <a:picLocks noChangeAspect="1"/>
+            </p:cNvPicPr>
+            <p:nvPr/>
+          </p:nvPicPr>
+          <p:blipFill>
+            <a:blip r:embed="rId5"/>
+            <a:stretch>
+              <a:fillRect/>
+            </a:stretch>
+          </p:blipFill>
+          <p:spPr>
+            <a:xfrm>
+              <a:off x="1784306" y="1259741"/>
+              <a:ext cx="8852828" cy="5257332"/>
+            </a:xfrm>
+            <a:prstGeom prst="rect">
+              <a:avLst/>
+            </a:prstGeom>
+          </p:spPr>
+        </p:pic>
+        <p:sp>
+          <p:nvSpPr>
+            <p:cNvPr id="18" name="In 2D">
+              <a:extLst>
+                <a:ext uri="{FF2B5EF4-FFF2-40B4-BE49-F238E27FC236}">
+                  <a16:creationId xmlns:a16="http://schemas.microsoft.com/office/drawing/2014/main" id="{C54900C6-43C7-A785-1F1F-CC88A598E574}"/>
+                </a:ext>
+              </a:extLst>
+            </p:cNvPr>
+            <p:cNvSpPr txBox="1"/>
+            <p:nvPr/>
+          </p:nvSpPr>
+          <p:spPr>
+            <a:xfrm>
+              <a:off x="2494472" y="3567596"/>
+              <a:ext cx="2509862" cy="291659"/>
+            </a:xfrm>
+            <a:prstGeom prst="rect">
+              <a:avLst/>
+            </a:prstGeom>
+            <a:ln w="12700">
+              <a:miter lim="400000"/>
+            </a:ln>
+            <a:extLst>
+              <a:ext uri="{C572A759-6A51-4108-AA02-DFA0A04FC94B}">
+                <ma14:wrappingTextBoxFlag xmlns="" xmlns:m="http://schemas.openxmlformats.org/officeDocument/2006/math" xmlns:a14="http://schemas.microsoft.com/office/drawing/2010/main" xmlns:ma14="http://schemas.microsoft.com/office/mac/drawingml/2011/main" val="1"/>
+              </a:ext>
+            </a:extLst>
+          </p:spPr>
+          <p:txBody>
+            <a:bodyPr lIns="33770" tIns="33770" rIns="33770" bIns="33770">
+              <a:spAutoFit/>
+            </a:bodyPr>
+            <a:lstStyle>
+              <a:lvl1pPr defTabSz="1007533">
+                <a:spcBef>
+                  <a:spcPts val="1000"/>
+                </a:spcBef>
+                <a:defRPr sz="1600" b="1" spc="0">
+                  <a:solidFill>
+                    <a:srgbClr val="CE181E"/>
+                  </a:solidFill>
+                </a:defRPr>
+              </a:lvl1pPr>
+            </a:lstStyle>
+            <a:p>
+              <a:r>
+                <a:rPr sz="1452" dirty="0">
+                  <a:solidFill>
+                    <a:srgbClr val="FFFF00"/>
+                  </a:solidFill>
+                </a:rPr>
+                <a:t>In 2D</a:t>
+              </a:r>
+            </a:p>
+          </p:txBody>
+        </p:sp>
+        <p:sp>
+          <p:nvSpPr>
+            <p:cNvPr id="19" name="1st and 2nd moments">
+              <a:extLst>
+                <a:ext uri="{FF2B5EF4-FFF2-40B4-BE49-F238E27FC236}">
+                  <a16:creationId xmlns:a16="http://schemas.microsoft.com/office/drawing/2014/main" id="{5487D8C3-C8B5-5C18-F4E5-083B5126DF04}"/>
+                </a:ext>
+              </a:extLst>
+            </p:cNvPr>
+            <p:cNvSpPr txBox="1"/>
+            <p:nvPr/>
+          </p:nvSpPr>
+          <p:spPr>
+            <a:xfrm>
+              <a:off x="8118560" y="3615145"/>
+              <a:ext cx="2289134" cy="291659"/>
+            </a:xfrm>
+            <a:prstGeom prst="rect">
+              <a:avLst/>
+            </a:prstGeom>
+            <a:ln w="12700">
+              <a:miter lim="400000"/>
+            </a:ln>
+            <a:extLst>
+              <a:ext uri="{C572A759-6A51-4108-AA02-DFA0A04FC94B}">
+                <ma14:wrappingTextBoxFlag xmlns="" xmlns:m="http://schemas.openxmlformats.org/officeDocument/2006/math" xmlns:a14="http://schemas.microsoft.com/office/drawing/2010/main" xmlns:ma14="http://schemas.microsoft.com/office/mac/drawingml/2011/main" val="1"/>
+              </a:ext>
+            </a:extLst>
+          </p:spPr>
+          <p:txBody>
+            <a:bodyPr lIns="33770" tIns="33770" rIns="33770" bIns="33770">
+              <a:spAutoFit/>
+            </a:bodyPr>
+            <a:lstStyle/>
+            <a:p>
+              <a:pPr defTabSz="914437">
+                <a:spcBef>
+                  <a:spcPts val="908"/>
+                </a:spcBef>
+                <a:defRPr sz="1600" b="1" spc="0">
+                  <a:solidFill>
+                    <a:srgbClr val="FFFFFE"/>
+                  </a:solidFill>
+                </a:defRPr>
+              </a:pPr>
+              <a:r>
+                <a:rPr sz="1452" dirty="0"/>
+                <a:t>1</a:t>
+              </a:r>
+              <a:r>
+                <a:rPr sz="1452" baseline="15746000" dirty="0"/>
+                <a:t>st</a:t>
+              </a:r>
+              <a:r>
+                <a:rPr sz="1452" dirty="0">
+                  <a:solidFill>
+                    <a:srgbClr val="CE181E"/>
+                  </a:solidFill>
+                </a:rPr>
+                <a:t> </a:t>
+              </a:r>
+              <a:r>
+                <a:rPr sz="1452" dirty="0">
+                  <a:solidFill>
+                    <a:srgbClr val="FFFF00"/>
+                  </a:solidFill>
+                </a:rPr>
+                <a:t>and</a:t>
+              </a:r>
+              <a:r>
+                <a:rPr sz="1452" dirty="0">
+                  <a:solidFill>
+                    <a:srgbClr val="CE181E"/>
+                  </a:solidFill>
+                </a:rPr>
+                <a:t> </a:t>
+              </a:r>
+              <a:r>
+                <a:rPr sz="1452" dirty="0">
+                  <a:solidFill>
+                    <a:srgbClr val="72E400"/>
+                  </a:solidFill>
+                </a:rPr>
+                <a:t>2</a:t>
+              </a:r>
+              <a:r>
+                <a:rPr sz="1452" baseline="15746000" dirty="0">
+                  <a:solidFill>
+                    <a:srgbClr val="72E400"/>
+                  </a:solidFill>
+                </a:rPr>
+                <a:t>nd</a:t>
+              </a:r>
+              <a:r>
+                <a:rPr sz="1452" dirty="0">
+                  <a:solidFill>
+                    <a:srgbClr val="72E400"/>
+                  </a:solidFill>
+                </a:rPr>
+                <a:t> </a:t>
+              </a:r>
+              <a:r>
+                <a:rPr sz="1452" dirty="0">
+                  <a:solidFill>
+                    <a:srgbClr val="FFFF00"/>
+                  </a:solidFill>
+                </a:rPr>
+                <a:t>moments</a:t>
+              </a:r>
+            </a:p>
+          </p:txBody>
+        </p:sp>
+        <p:sp>
+          <p:nvSpPr>
+            <p:cNvPr id="20" name="Line">
+              <a:extLst>
+                <a:ext uri="{FF2B5EF4-FFF2-40B4-BE49-F238E27FC236}">
+                  <a16:creationId xmlns:a16="http://schemas.microsoft.com/office/drawing/2014/main" id="{C9D45225-801C-4A73-24DB-94539406F7EA}"/>
+                </a:ext>
+              </a:extLst>
+            </p:cNvPr>
+            <p:cNvSpPr/>
+            <p:nvPr/>
+          </p:nvSpPr>
+          <p:spPr>
+            <a:xfrm flipV="1">
+              <a:off x="8307137" y="2117725"/>
+              <a:ext cx="687638" cy="1497420"/>
+            </a:xfrm>
+            <a:prstGeom prst="line">
+              <a:avLst/>
+            </a:prstGeom>
+            <a:ln w="25400">
+              <a:solidFill>
+                <a:srgbClr val="FFFFFF"/>
+              </a:solidFill>
+              <a:tailEnd type="triangle"/>
+            </a:ln>
+          </p:spPr>
+          <p:txBody>
+            <a:bodyPr lIns="34311" tIns="34311" rIns="34311" bIns="34311"/>
+            <a:lstStyle/>
+            <a:p>
+              <a:pPr defTabSz="914437">
+                <a:spcBef>
+                  <a:spcPts val="908"/>
+                </a:spcBef>
+                <a:defRPr sz="1600"/>
+              </a:pPr>
+              <a:endParaRPr sz="1452"/>
+            </a:p>
+          </p:txBody>
+        </p:sp>
+        <p:sp>
+          <p:nvSpPr>
+            <p:cNvPr id="21" name="Line">
+              <a:extLst>
+                <a:ext uri="{FF2B5EF4-FFF2-40B4-BE49-F238E27FC236}">
+                  <a16:creationId xmlns:a16="http://schemas.microsoft.com/office/drawing/2014/main" id="{CA1AB7D1-2180-D50A-C02E-BF6CA2E4DFB7}"/>
+                </a:ext>
+              </a:extLst>
+            </p:cNvPr>
+            <p:cNvSpPr/>
+            <p:nvPr/>
+          </p:nvSpPr>
+          <p:spPr>
+            <a:xfrm flipV="1">
+              <a:off x="8847474" y="2152455"/>
+              <a:ext cx="820401" cy="1462689"/>
+            </a:xfrm>
+            <a:prstGeom prst="line">
+              <a:avLst/>
+            </a:prstGeom>
+            <a:ln w="25400">
+              <a:solidFill>
+                <a:srgbClr val="72E400"/>
+              </a:solidFill>
+              <a:tailEnd type="triangle"/>
+            </a:ln>
+          </p:spPr>
+          <p:txBody>
+            <a:bodyPr lIns="34311" tIns="34311" rIns="34311" bIns="34311"/>
+            <a:lstStyle/>
+            <a:p>
+              <a:pPr defTabSz="914437">
+                <a:spcBef>
+                  <a:spcPts val="908"/>
+                </a:spcBef>
+                <a:defRPr sz="1600"/>
+              </a:pPr>
+              <a:endParaRPr sz="1452"/>
+            </a:p>
+          </p:txBody>
+        </p:sp>
+        <p:sp>
+          <p:nvSpPr>
+            <p:cNvPr id="22" name="Line">
+              <a:extLst>
+                <a:ext uri="{FF2B5EF4-FFF2-40B4-BE49-F238E27FC236}">
+                  <a16:creationId xmlns:a16="http://schemas.microsoft.com/office/drawing/2014/main" id="{1F36A507-218C-308E-785A-FE7C80B5DA31}"/>
+                </a:ext>
+              </a:extLst>
+            </p:cNvPr>
+            <p:cNvSpPr/>
+            <p:nvPr/>
+          </p:nvSpPr>
+          <p:spPr>
+            <a:xfrm flipH="1" flipV="1">
+              <a:off x="7902574" y="2117725"/>
+              <a:ext cx="269479" cy="1439606"/>
+            </a:xfrm>
+            <a:prstGeom prst="line">
+              <a:avLst/>
+            </a:prstGeom>
+            <a:ln w="25400">
+              <a:solidFill>
+                <a:srgbClr val="FFFFFF"/>
+              </a:solidFill>
+              <a:tailEnd type="triangle"/>
+            </a:ln>
+          </p:spPr>
+          <p:txBody>
+            <a:bodyPr lIns="34311" tIns="34311" rIns="34311" bIns="34311"/>
+            <a:lstStyle/>
+            <a:p>
+              <a:pPr defTabSz="914437">
+                <a:spcBef>
+                  <a:spcPts val="908"/>
+                </a:spcBef>
+                <a:defRPr sz="1600"/>
+              </a:pPr>
+              <a:endParaRPr sz="1452"/>
+            </a:p>
+          </p:txBody>
+        </p:sp>
+        <p:sp>
+          <p:nvSpPr>
+            <p:cNvPr id="23" name="Line">
+              <a:extLst>
+                <a:ext uri="{FF2B5EF4-FFF2-40B4-BE49-F238E27FC236}">
+                  <a16:creationId xmlns:a16="http://schemas.microsoft.com/office/drawing/2014/main" id="{FA7332FD-E796-A21B-B947-862AA6901B35}"/>
+                </a:ext>
+              </a:extLst>
+            </p:cNvPr>
+            <p:cNvSpPr/>
+            <p:nvPr/>
+          </p:nvSpPr>
+          <p:spPr>
+            <a:xfrm flipH="1" flipV="1">
+              <a:off x="8466786" y="2152453"/>
+              <a:ext cx="245604" cy="1415142"/>
+            </a:xfrm>
+            <a:prstGeom prst="line">
+              <a:avLst/>
+            </a:prstGeom>
+            <a:ln w="25400">
+              <a:solidFill>
+                <a:srgbClr val="72E400"/>
+              </a:solidFill>
+              <a:tailEnd type="triangle"/>
+            </a:ln>
+          </p:spPr>
+          <p:txBody>
+            <a:bodyPr lIns="34311" tIns="34311" rIns="34311" bIns="34311"/>
+            <a:lstStyle/>
+            <a:p>
+              <a:pPr defTabSz="914437">
+                <a:spcBef>
+                  <a:spcPts val="908"/>
+                </a:spcBef>
+                <a:defRPr sz="1600"/>
+              </a:pPr>
+              <a:endParaRPr sz="1452"/>
+            </a:p>
+          </p:txBody>
+        </p:sp>
+      </p:grpSp>
+      <p:sp>
+        <p:nvSpPr>
+          <p:cNvPr id="25" name="TextBox 24">
+            <a:extLst>
+              <a:ext uri="{FF2B5EF4-FFF2-40B4-BE49-F238E27FC236}">
+                <a16:creationId xmlns:a16="http://schemas.microsoft.com/office/drawing/2014/main" id="{CA5260D0-F184-E676-6B31-AFFF5380B622}"/>
+              </a:ext>
+            </a:extLst>
+          </p:cNvPr>
+          <p:cNvSpPr txBox="1"/>
+          <p:nvPr/>
+        </p:nvSpPr>
+        <p:spPr>
+          <a:xfrm>
+            <a:off x="119699" y="5191035"/>
+            <a:ext cx="6817041" cy="1200329"/>
+          </a:xfrm>
+          <a:prstGeom prst="rect">
+            <a:avLst/>
+          </a:prstGeom>
+          <a:noFill/>
+          <a:ln>
+            <a:solidFill>
+              <a:schemeClr val="accent1"/>
+            </a:solidFill>
+          </a:ln>
+        </p:spPr>
+        <p:txBody>
+          <a:bodyPr wrap="square" rtlCol="0">
+            <a:spAutoFit/>
+          </a:bodyPr>
+          <a:lstStyle/>
+          <a:p>
+            <a:r>
+              <a:rPr lang="en-DK" dirty="0"/>
+              <a:t>Plotting tools are </a:t>
+            </a:r>
+            <a:r>
+              <a:rPr lang="en-DK" dirty="0">
+                <a:solidFill>
+                  <a:srgbClr val="0070C0"/>
+                </a:solidFill>
+              </a:rPr>
+              <a:t>mcplot</a:t>
+            </a:r>
+            <a:r>
+              <a:rPr lang="en-DK" dirty="0"/>
+              <a:t>(-pyqtgraph/-matplotlib/-html) for McStas and</a:t>
+            </a:r>
+            <a:br>
+              <a:rPr lang="en-DK" dirty="0"/>
+            </a:br>
+            <a:r>
+              <a:rPr lang="en-DK" dirty="0"/>
+              <a:t>                               </a:t>
+            </a:r>
+            <a:r>
+              <a:rPr lang="en-DK" dirty="0">
+                <a:solidFill>
+                  <a:srgbClr val="FF0000"/>
+                </a:solidFill>
+              </a:rPr>
+              <a:t>mxplot-</a:t>
+            </a:r>
+            <a:r>
+              <a:rPr lang="en-DK" dirty="0"/>
+              <a:t>(-pyqtgraph/-matplotlib/-html) for McXtrace </a:t>
+            </a:r>
+          </a:p>
+          <a:p>
+            <a:endParaRPr lang="en-DK" dirty="0"/>
+          </a:p>
+          <a:p>
+            <a:r>
+              <a:rPr lang="en-DK" dirty="0"/>
+              <a:t>There are further </a:t>
+            </a:r>
+            <a:r>
+              <a:rPr lang="en-DK" dirty="0">
+                <a:solidFill>
+                  <a:srgbClr val="0070C0"/>
+                </a:solidFill>
+              </a:rPr>
+              <a:t>mccoplot</a:t>
+            </a:r>
+            <a:r>
+              <a:rPr lang="en-DK" dirty="0"/>
+              <a:t>/</a:t>
+            </a:r>
+            <a:r>
+              <a:rPr lang="en-DK" dirty="0">
+                <a:solidFill>
+                  <a:srgbClr val="FF0000"/>
+                </a:solidFill>
+              </a:rPr>
+              <a:t>mxcoplot</a:t>
+            </a:r>
+            <a:r>
+              <a:rPr lang="en-DK" dirty="0"/>
+              <a:t> and </a:t>
+            </a:r>
+            <a:r>
+              <a:rPr lang="en-DK" dirty="0">
+                <a:solidFill>
+                  <a:srgbClr val="0070C0"/>
+                </a:solidFill>
+              </a:rPr>
+              <a:t>mcplotdiff</a:t>
+            </a:r>
+            <a:r>
+              <a:rPr lang="en-DK" dirty="0"/>
+              <a:t>/</a:t>
+            </a:r>
+            <a:r>
+              <a:rPr lang="en-DK" dirty="0">
+                <a:solidFill>
+                  <a:srgbClr val="FF0000"/>
+                </a:solidFill>
+              </a:rPr>
+              <a:t>mxplotdiff</a:t>
+            </a:r>
+            <a:r>
+              <a:rPr lang="en-DK" dirty="0"/>
+              <a:t> tools</a:t>
+            </a:r>
+          </a:p>
+        </p:txBody>
+      </p:sp>
+      <p:sp>
+        <p:nvSpPr>
+          <p:cNvPr id="26" name="TextBox 25">
+            <a:extLst>
+              <a:ext uri="{FF2B5EF4-FFF2-40B4-BE49-F238E27FC236}">
+                <a16:creationId xmlns:a16="http://schemas.microsoft.com/office/drawing/2014/main" id="{81D6ADFB-FC9A-118B-8324-E4529871186F}"/>
+              </a:ext>
+            </a:extLst>
+          </p:cNvPr>
+          <p:cNvSpPr txBox="1"/>
+          <p:nvPr/>
+        </p:nvSpPr>
+        <p:spPr>
+          <a:xfrm>
+            <a:off x="7075762" y="5203123"/>
+            <a:ext cx="4983839" cy="1200329"/>
+          </a:xfrm>
+          <a:prstGeom prst="rect">
+            <a:avLst/>
+          </a:prstGeom>
+          <a:noFill/>
+          <a:ln>
+            <a:solidFill>
+              <a:schemeClr val="accent1"/>
+            </a:solidFill>
+          </a:ln>
+        </p:spPr>
+        <p:txBody>
+          <a:bodyPr wrap="square" rtlCol="0">
+            <a:spAutoFit/>
+          </a:bodyPr>
+          <a:lstStyle/>
+          <a:p>
+            <a:r>
+              <a:rPr lang="en-DK" dirty="0"/>
+              <a:t>When output is written in HDF5 / NeXus format we </a:t>
+            </a:r>
+            <a:br>
+              <a:rPr lang="en-DK" dirty="0"/>
+            </a:br>
+            <a:r>
+              <a:rPr lang="en-DK" dirty="0"/>
+              <a:t>recommend the ‘</a:t>
+            </a:r>
+            <a:r>
+              <a:rPr lang="en-DK" dirty="0">
+                <a:solidFill>
+                  <a:schemeClr val="accent6">
+                    <a:lumMod val="75000"/>
+                  </a:schemeClr>
+                </a:solidFill>
+              </a:rPr>
+              <a:t>nexpy</a:t>
+            </a:r>
+            <a:r>
+              <a:rPr lang="en-DK" dirty="0"/>
+              <a:t>’ software</a:t>
+            </a:r>
+            <a:br>
+              <a:rPr lang="en-DK" dirty="0"/>
+            </a:br>
+            <a:br>
+              <a:rPr lang="en-DK" dirty="0"/>
+            </a:br>
+            <a:r>
+              <a:rPr lang="en-DK" dirty="0"/>
+              <a:t> (always included when installing from conda-forge)</a:t>
+            </a:r>
+          </a:p>
+        </p:txBody>
+      </p:sp>
+      <p:sp>
+        <p:nvSpPr>
+          <p:cNvPr id="28" name="TextBox 27">
+            <a:extLst>
+              <a:ext uri="{FF2B5EF4-FFF2-40B4-BE49-F238E27FC236}">
+                <a16:creationId xmlns:a16="http://schemas.microsoft.com/office/drawing/2014/main" id="{3BD150F3-C0D3-DD01-8EDB-A7CE317E4045}"/>
+              </a:ext>
+            </a:extLst>
+          </p:cNvPr>
+          <p:cNvSpPr txBox="1"/>
+          <p:nvPr/>
+        </p:nvSpPr>
+        <p:spPr>
+          <a:xfrm>
+            <a:off x="2976514" y="6446520"/>
+            <a:ext cx="8271880" cy="369332"/>
+          </a:xfrm>
+          <a:prstGeom prst="rect">
+            <a:avLst/>
+          </a:prstGeom>
+          <a:noFill/>
+          <a:ln>
+            <a:solidFill>
+              <a:schemeClr val="accent1"/>
+            </a:solidFill>
+          </a:ln>
+        </p:spPr>
+        <p:txBody>
+          <a:bodyPr wrap="none" rtlCol="0">
+            <a:spAutoFit/>
+          </a:bodyPr>
+          <a:lstStyle/>
+          <a:p>
+            <a:r>
+              <a:rPr lang="en-DK" dirty="0"/>
+              <a:t>When a particle event-list is the suitable format, this can be created using Monitor_nD</a:t>
+            </a:r>
+          </a:p>
+        </p:txBody>
+      </p:sp>
+    </p:spTree>
+    <p:extLst>
+      <p:ext uri="{BB962C8B-B14F-4D97-AF65-F5344CB8AC3E}">
+        <p14:creationId xmlns:p14="http://schemas.microsoft.com/office/powerpoint/2010/main" val="1397418551"/>
+      </p:ext>
+    </p:extLst>
+  </p:cSld>
+  <p:clrMapOvr>
+    <a:masterClrMapping/>
+  </p:clrMapOvr>
+</p:sld>
+</file>
+
+<file path=ppt/slides/slide17.xml><?xml version="1.0" encoding="utf-8"?>
+<p:sld xmlns:a="http://schemas.openxmlformats.org/drawingml/2006/main" xmlns:r="http://schemas.openxmlformats.org/officeDocument/2006/relationships" xmlns:p="http://schemas.openxmlformats.org/presentationml/2006/main">
   <p:cSld name="Slide 16">
     <p:bg>
       <p:bgPr>
@@ -7363,7 +9394,7 @@
 </p:sld>
 </file>
 
-<file path=ppt/slides/slide17.xml><?xml version="1.0" encoding="utf-8"?>
+<file path=ppt/slides/slide18.xml><?xml version="1.0" encoding="utf-8"?>
 <p:sld xmlns:a="http://schemas.openxmlformats.org/drawingml/2006/main" xmlns:r="http://schemas.openxmlformats.org/officeDocument/2006/relationships" xmlns:p="http://schemas.openxmlformats.org/presentationml/2006/main">
   <p:cSld name="Slide 17">
     <p:bg>
@@ -7798,7 +9829,7 @@
               <a:buNone/>
             </a:pPr>
             <a:r>
-              <a:rPr lang="en-US" sz="1250" dirty="0">
+              <a:rPr lang="en-US" sz="1250" dirty="0" err="1">
                 <a:solidFill>
                   <a:srgbClr val="E6E9F5"/>
                 </a:solidFill>
@@ -7807,6 +9838,17 @@
                 <a:cs typeface="Courier New" pitchFamily="34" charset="-120"/>
               </a:rPr>
               <a:t>mcxtrace.org</a:t>
+            </a:r>
+            <a:r>
+              <a:rPr lang="en-US" sz="1250" dirty="0">
+                <a:solidFill>
+                  <a:srgbClr val="E6E9F5"/>
+                </a:solidFill>
+                <a:latin typeface="Courier New" pitchFamily="34" charset="0"/>
+                <a:ea typeface="Courier New" pitchFamily="34" charset="-122"/>
+                <a:cs typeface="Courier New" pitchFamily="34" charset="-120"/>
+              </a:rPr>
+              <a:t>/download/components</a:t>
             </a:r>
             <a:endParaRPr lang="en-US" sz="1250" dirty="0"/>
           </a:p>
@@ -10315,7 +12357,7 @@
         </p:nvGraphicFramePr>
         <p:xfrm>
           <a:off x="548640" y="2057400"/>
-          <a:ext cx="11064240" cy="914400"/>
+          <a:ext cx="11064240" cy="2743200"/>
         </p:xfrm>
         <a:graphic>
           <a:graphicData uri="http://schemas.openxmlformats.org/drawingml/2006/table">
@@ -14275,7 +16317,7 @@
                 <a:ea typeface="Calibri" pitchFamily="34" charset="-122"/>
                 <a:cs typeface="Calibri" pitchFamily="34" charset="-120"/>
               </a:rPr>
-              <a:t>A real source emits into the full 4π steradian — but a simulation only needs the solid angle Ω subtended by the beamline's first aperture.</a:t>
+              <a:t>Most neutron- and some X-ray sources emit into the full 4π steradian — but a simulation only needs the solid angle Ω subtended by the beamline's first aperture.</a:t>
             </a:r>
             <a:endParaRPr lang="en-US" sz="1250" dirty="0"/>
           </a:p>
@@ -14380,33 +16422,6 @@
       </p:sp>
       <p:sp>
         <p:nvSpPr>
-          <p:cNvPr id="7" name="Shape 4"/>
-          <p:cNvSpPr/>
-          <p:nvPr/>
-        </p:nvSpPr>
-        <p:spPr>
-          <a:xfrm>
-            <a:off x="7141464" y="3666744"/>
-            <a:ext cx="164592" cy="164592"/>
-          </a:xfrm>
-          <a:prstGeom prst="ellipse">
-            <a:avLst/>
-          </a:prstGeom>
-          <a:solidFill>
-            <a:srgbClr val="20242B"/>
-          </a:solidFill>
-          <a:ln/>
-        </p:spPr>
-        <p:txBody>
-          <a:bodyPr/>
-          <a:lstStyle/>
-          <a:p>
-            <a:endParaRPr lang="en-DK"/>
-          </a:p>
-        </p:txBody>
-      </p:sp>
-      <p:sp>
-        <p:nvSpPr>
           <p:cNvPr id="8" name="Text 5"/>
           <p:cNvSpPr/>
           <p:nvPr/>
@@ -14446,104 +16461,14 @@
       </p:sp>
       <p:sp>
         <p:nvSpPr>
-          <p:cNvPr id="9" name="Shape 6"/>
-          <p:cNvSpPr/>
-          <p:nvPr/>
-        </p:nvSpPr>
-        <p:spPr>
-          <a:xfrm>
-            <a:off x="7223760" y="3749040"/>
-            <a:ext cx="3520440" cy="0"/>
-          </a:xfrm>
-          <a:prstGeom prst="line">
-            <a:avLst/>
-          </a:prstGeom>
-          <a:noFill/>
-          <a:ln w="19050">
-            <a:solidFill>
-              <a:srgbClr val="1C7293"/>
-            </a:solidFill>
-            <a:prstDash val="solid"/>
-          </a:ln>
-        </p:spPr>
-        <p:txBody>
-          <a:bodyPr/>
-          <a:lstStyle/>
-          <a:p>
-            <a:endParaRPr lang="en-DK"/>
-          </a:p>
-        </p:txBody>
-      </p:sp>
-      <p:sp>
-        <p:nvSpPr>
-          <p:cNvPr id="10" name="Shape 7"/>
-          <p:cNvSpPr/>
-          <p:nvPr/>
-        </p:nvSpPr>
-        <p:spPr>
-          <a:xfrm>
-            <a:off x="7223760" y="3749040"/>
-            <a:ext cx="3520440" cy="1005840"/>
-          </a:xfrm>
-          <a:prstGeom prst="line">
-            <a:avLst/>
-          </a:prstGeom>
-          <a:noFill/>
-          <a:ln w="19050">
-            <a:solidFill>
-              <a:srgbClr val="1C7293"/>
-            </a:solidFill>
-            <a:prstDash val="solid"/>
-          </a:ln>
-        </p:spPr>
-        <p:txBody>
-          <a:bodyPr/>
-          <a:lstStyle/>
-          <a:p>
-            <a:endParaRPr lang="en-DK"/>
-          </a:p>
-        </p:txBody>
-      </p:sp>
-      <p:sp>
-        <p:nvSpPr>
-          <p:cNvPr id="11" name="Shape 8"/>
-          <p:cNvSpPr/>
-          <p:nvPr/>
-        </p:nvSpPr>
-        <p:spPr>
-          <a:xfrm>
-            <a:off x="10744200" y="2743200"/>
-            <a:ext cx="0" cy="2011680"/>
-          </a:xfrm>
-          <a:prstGeom prst="line">
-            <a:avLst/>
-          </a:prstGeom>
-          <a:noFill/>
-          <a:ln w="38100">
-            <a:solidFill>
-              <a:srgbClr val="D97A2B"/>
-            </a:solidFill>
-            <a:prstDash val="solid"/>
-          </a:ln>
-        </p:spPr>
-        <p:txBody>
-          <a:bodyPr/>
-          <a:lstStyle/>
-          <a:p>
-            <a:endParaRPr lang="en-DK"/>
-          </a:p>
-        </p:txBody>
-      </p:sp>
-      <p:sp>
-        <p:nvSpPr>
-          <p:cNvPr id="12" name="Text 9"/>
-          <p:cNvSpPr/>
-          <p:nvPr/>
-        </p:nvSpPr>
-        <p:spPr>
-          <a:xfrm>
-            <a:off x="8709660" y="3063240"/>
-            <a:ext cx="548640" cy="365760"/>
+          <p:cNvPr id="14" name="Text 11"/>
+          <p:cNvSpPr/>
+          <p:nvPr/>
+        </p:nvSpPr>
+        <p:spPr>
+          <a:xfrm>
+            <a:off x="6766560" y="4754880"/>
+            <a:ext cx="4526280" cy="868680"/>
           </a:xfrm>
           <a:prstGeom prst="rect">
             <a:avLst/>
@@ -14559,46 +16484,7 @@
               <a:buNone/>
             </a:pPr>
             <a:r>
-              <a:rPr lang="en-US" sz="1600" b="1" dirty="0">
-                <a:solidFill>
-                  <a:srgbClr val="12506B"/>
-                </a:solidFill>
-                <a:latin typeface="Cambria" pitchFamily="34" charset="0"/>
-                <a:ea typeface="Cambria" pitchFamily="34" charset="-122"/>
-                <a:cs typeface="Cambria" pitchFamily="34" charset="-120"/>
-              </a:rPr>
-              <a:t>Ω</a:t>
-            </a:r>
-            <a:endParaRPr lang="en-US" sz="1600" dirty="0"/>
-          </a:p>
-        </p:txBody>
-      </p:sp>
-      <p:sp>
-        <p:nvSpPr>
-          <p:cNvPr id="13" name="Text 10"/>
-          <p:cNvSpPr/>
-          <p:nvPr/>
-        </p:nvSpPr>
-        <p:spPr>
-          <a:xfrm>
-            <a:off x="10195560" y="4846320"/>
-            <a:ext cx="1097280" cy="274320"/>
-          </a:xfrm>
-          <a:prstGeom prst="rect">
-            <a:avLst/>
-          </a:prstGeom>
-          <a:noFill/>
-          <a:ln/>
-        </p:spPr>
-        <p:txBody>
-          <a:bodyPr wrap="square" rtlCol="0" anchor="ctr"/>
-          <a:lstStyle/>
-          <a:p>
-            <a:pPr marL="0" indent="0" algn="ctr">
-              <a:buNone/>
-            </a:pPr>
-            <a:r>
-              <a:rPr lang="en-US" sz="1000" dirty="0">
+              <a:rPr lang="en-US" sz="1100" i="1" dirty="0">
                 <a:solidFill>
                   <a:srgbClr val="6E7580"/>
                 </a:solidFill>
@@ -14606,38 +16492,38 @@
                 <a:ea typeface="Calibri" pitchFamily="34" charset="-122"/>
                 <a:cs typeface="Calibri" pitchFamily="34" charset="-120"/>
               </a:rPr>
-              <a:t>aperture</a:t>
-            </a:r>
-            <a:endParaRPr lang="en-US" sz="1000" dirty="0"/>
-          </a:p>
-        </p:txBody>
-      </p:sp>
-      <p:sp>
-        <p:nvSpPr>
-          <p:cNvPr id="14" name="Text 11"/>
-          <p:cNvSpPr/>
-          <p:nvPr/>
-        </p:nvSpPr>
-        <p:spPr>
-          <a:xfrm>
-            <a:off x="6766560" y="4754880"/>
-            <a:ext cx="4526280" cy="868680"/>
-          </a:xfrm>
-          <a:prstGeom prst="rect">
-            <a:avLst/>
-          </a:prstGeom>
-          <a:noFill/>
-          <a:ln/>
-        </p:spPr>
-        <p:txBody>
-          <a:bodyPr wrap="square" rtlCol="0" anchor="ctr"/>
-          <a:lstStyle/>
-          <a:p>
-            <a:pPr marL="0" indent="0" algn="ctr">
-              <a:buNone/>
-            </a:pPr>
-            <a:r>
-              <a:rPr lang="en-US" sz="1100" i="1" dirty="0">
+              <a:t>Many low-weight rays, or fewer high-weight rays — the physical result comes out the same, but statistics (and runtime) differ.</a:t>
+            </a:r>
+            <a:endParaRPr lang="en-US" sz="1100" dirty="0"/>
+          </a:p>
+        </p:txBody>
+      </p:sp>
+      <p:sp>
+        <p:nvSpPr>
+          <p:cNvPr id="15" name="Text 12"/>
+          <p:cNvSpPr/>
+          <p:nvPr/>
+        </p:nvSpPr>
+        <p:spPr>
+          <a:xfrm>
+            <a:off x="548640" y="6446520"/>
+            <a:ext cx="6400800" cy="274320"/>
+          </a:xfrm>
+          <a:prstGeom prst="rect">
+            <a:avLst/>
+          </a:prstGeom>
+          <a:noFill/>
+          <a:ln/>
+        </p:spPr>
+        <p:txBody>
+          <a:bodyPr wrap="square" rtlCol="0" anchor="ctr"/>
+          <a:lstStyle/>
+          <a:p>
+            <a:pPr marL="0" indent="0" algn="l">
+              <a:buNone/>
+            </a:pPr>
+            <a:r>
+              <a:rPr lang="en-US" sz="900" dirty="0">
                 <a:solidFill>
                   <a:srgbClr val="6E7580"/>
                 </a:solidFill>
@@ -14645,34 +16531,34 @@
                 <a:ea typeface="Calibri" pitchFamily="34" charset="-122"/>
                 <a:cs typeface="Calibri" pitchFamily="34" charset="-120"/>
               </a:rPr>
-              <a:t>Many low-weight rays, or fewer high-weight rays — the physical result comes out the same, but statistics (and runtime) differ.</a:t>
-            </a:r>
-            <a:endParaRPr lang="en-US" sz="1100" dirty="0"/>
-          </a:p>
-        </p:txBody>
-      </p:sp>
-      <p:sp>
-        <p:nvSpPr>
-          <p:cNvPr id="15" name="Text 12"/>
-          <p:cNvSpPr/>
-          <p:nvPr/>
-        </p:nvSpPr>
-        <p:spPr>
-          <a:xfrm>
-            <a:off x="548640" y="6446520"/>
-            <a:ext cx="6400800" cy="274320"/>
-          </a:xfrm>
-          <a:prstGeom prst="rect">
-            <a:avLst/>
-          </a:prstGeom>
-          <a:noFill/>
-          <a:ln/>
-        </p:spPr>
-        <p:txBody>
-          <a:bodyPr wrap="square" rtlCol="0" anchor="ctr"/>
-          <a:lstStyle/>
-          <a:p>
-            <a:pPr marL="0" indent="0" algn="l">
+              <a:t>McStas &amp; McXtrace  ·  Sources &amp; Monitors</a:t>
+            </a:r>
+            <a:endParaRPr lang="en-US" sz="900" dirty="0"/>
+          </a:p>
+        </p:txBody>
+      </p:sp>
+      <p:sp>
+        <p:nvSpPr>
+          <p:cNvPr id="16" name="Text 13"/>
+          <p:cNvSpPr/>
+          <p:nvPr/>
+        </p:nvSpPr>
+        <p:spPr>
+          <a:xfrm>
+            <a:off x="11185855" y="6446520"/>
+            <a:ext cx="457200" cy="274320"/>
+          </a:xfrm>
+          <a:prstGeom prst="rect">
+            <a:avLst/>
+          </a:prstGeom>
+          <a:noFill/>
+          <a:ln/>
+        </p:spPr>
+        <p:txBody>
+          <a:bodyPr wrap="square" rtlCol="0" anchor="ctr"/>
+          <a:lstStyle/>
+          <a:p>
+            <a:pPr marL="0" indent="0" algn="r">
               <a:buNone/>
             </a:pPr>
             <a:r>
@@ -14684,51 +16570,969 @@
                 <a:ea typeface="Calibri" pitchFamily="34" charset="-122"/>
                 <a:cs typeface="Calibri" pitchFamily="34" charset="-120"/>
               </a:rPr>
-              <a:t>McStas &amp; McXtrace  ·  Sources &amp; Monitors</a:t>
+              <a:t>8</a:t>
             </a:r>
             <a:endParaRPr lang="en-US" sz="900" dirty="0"/>
           </a:p>
         </p:txBody>
       </p:sp>
-      <p:sp>
-        <p:nvSpPr>
-          <p:cNvPr id="16" name="Text 13"/>
-          <p:cNvSpPr/>
-          <p:nvPr/>
-        </p:nvSpPr>
-        <p:spPr>
-          <a:xfrm>
-            <a:off x="11185855" y="6446520"/>
-            <a:ext cx="457200" cy="274320"/>
-          </a:xfrm>
-          <a:prstGeom prst="rect">
-            <a:avLst/>
-          </a:prstGeom>
-          <a:noFill/>
-          <a:ln/>
-        </p:spPr>
-        <p:txBody>
-          <a:bodyPr wrap="square" rtlCol="0" anchor="ctr"/>
-          <a:lstStyle/>
-          <a:p>
-            <a:pPr marL="0" indent="0" algn="r">
-              <a:buNone/>
-            </a:pPr>
-            <a:r>
-              <a:rPr lang="en-US" sz="900" dirty="0">
-                <a:solidFill>
-                  <a:srgbClr val="6E7580"/>
-                </a:solidFill>
-                <a:latin typeface="Calibri" pitchFamily="34" charset="0"/>
-                <a:ea typeface="Calibri" pitchFamily="34" charset="-122"/>
-                <a:cs typeface="Calibri" pitchFamily="34" charset="-120"/>
-              </a:rPr>
-              <a:t>8</a:t>
-            </a:r>
-            <a:endParaRPr lang="en-US" sz="900" dirty="0"/>
-          </a:p>
-        </p:txBody>
-      </p:sp>
+      <p:grpSp>
+        <p:nvGrpSpPr>
+          <p:cNvPr id="39" name="Group 38">
+            <a:extLst>
+              <a:ext uri="{FF2B5EF4-FFF2-40B4-BE49-F238E27FC236}">
+                <a16:creationId xmlns:a16="http://schemas.microsoft.com/office/drawing/2014/main" id="{0ECF213B-499A-B257-6E82-DC4CE8102147}"/>
+              </a:ext>
+            </a:extLst>
+          </p:cNvPr>
+          <p:cNvGrpSpPr/>
+          <p:nvPr/>
+        </p:nvGrpSpPr>
+        <p:grpSpPr>
+          <a:xfrm>
+            <a:off x="6523571" y="2304288"/>
+            <a:ext cx="5086043" cy="2572531"/>
+            <a:chOff x="1642044" y="222901"/>
+            <a:chExt cx="10277103" cy="4700723"/>
+          </a:xfrm>
+        </p:grpSpPr>
+        <p:grpSp>
+          <p:nvGrpSpPr>
+            <p:cNvPr id="17" name="Group">
+              <a:extLst>
+                <a:ext uri="{FF2B5EF4-FFF2-40B4-BE49-F238E27FC236}">
+                  <a16:creationId xmlns:a16="http://schemas.microsoft.com/office/drawing/2014/main" id="{8B635996-0D02-99A0-67ED-D96CA18F2E63}"/>
+                </a:ext>
+              </a:extLst>
+            </p:cNvPr>
+            <p:cNvGrpSpPr/>
+            <p:nvPr/>
+          </p:nvGrpSpPr>
+          <p:grpSpPr>
+            <a:xfrm>
+              <a:off x="1642044" y="1934376"/>
+              <a:ext cx="3040396" cy="2989248"/>
+              <a:chOff x="0" y="0"/>
+              <a:chExt cx="3040394" cy="2989247"/>
+            </a:xfrm>
+          </p:grpSpPr>
+          <p:sp>
+            <p:nvSpPr>
+              <p:cNvPr id="18" name="Line">
+                <a:extLst>
+                  <a:ext uri="{FF2B5EF4-FFF2-40B4-BE49-F238E27FC236}">
+                    <a16:creationId xmlns:a16="http://schemas.microsoft.com/office/drawing/2014/main" id="{773CCA7C-FB59-0264-E3C9-7FBC147C0B1D}"/>
+                  </a:ext>
+                </a:extLst>
+              </p:cNvPr>
+              <p:cNvSpPr/>
+              <p:nvPr/>
+            </p:nvSpPr>
+            <p:spPr>
+              <a:xfrm flipV="1">
+                <a:off x="1818705" y="785843"/>
+                <a:ext cx="1221690" cy="441148"/>
+              </a:xfrm>
+              <a:prstGeom prst="line">
+                <a:avLst/>
+              </a:prstGeom>
+              <a:noFill/>
+              <a:ln w="25400" cap="flat">
+                <a:solidFill>
+                  <a:schemeClr val="accent2">
+                    <a:lumOff val="11225"/>
+                  </a:schemeClr>
+                </a:solidFill>
+                <a:prstDash val="solid"/>
+                <a:round/>
+                <a:tailEnd type="triangle" w="med" len="med"/>
+              </a:ln>
+              <a:effectLst>
+                <a:outerShdw blurRad="38100" dist="20000" dir="5400000" rotWithShape="0">
+                  <a:srgbClr val="000000">
+                    <a:alpha val="38000"/>
+                  </a:srgbClr>
+                </a:outerShdw>
+              </a:effectLst>
+            </p:spPr>
+            <p:txBody>
+              <a:bodyPr wrap="square" lIns="45719" tIns="45719" rIns="45719" bIns="45719" numCol="1" anchor="t">
+                <a:noAutofit/>
+              </a:bodyPr>
+              <a:lstStyle/>
+              <a:p>
+                <a:endParaRPr/>
+              </a:p>
+            </p:txBody>
+          </p:sp>
+          <p:sp>
+            <p:nvSpPr>
+              <p:cNvPr id="19" name="Oval">
+                <a:extLst>
+                  <a:ext uri="{FF2B5EF4-FFF2-40B4-BE49-F238E27FC236}">
+                    <a16:creationId xmlns:a16="http://schemas.microsoft.com/office/drawing/2014/main" id="{289DF42C-3811-CAEF-5BB0-5F6EDA20E49F}"/>
+                  </a:ext>
+                </a:extLst>
+              </p:cNvPr>
+              <p:cNvSpPr/>
+              <p:nvPr/>
+            </p:nvSpPr>
+            <p:spPr>
+              <a:xfrm>
+                <a:off x="764605" y="477225"/>
+                <a:ext cx="1270001" cy="388591"/>
+              </a:xfrm>
+              <a:prstGeom prst="ellipse">
+                <a:avLst/>
+              </a:prstGeom>
+              <a:solidFill>
+                <a:srgbClr val="FFFFFF"/>
+              </a:solidFill>
+              <a:ln w="25400" cap="flat">
+                <a:solidFill>
+                  <a:schemeClr val="accent1"/>
+                </a:solidFill>
+                <a:prstDash val="solid"/>
+                <a:round/>
+              </a:ln>
+              <a:effectLst/>
+            </p:spPr>
+            <p:txBody>
+              <a:bodyPr wrap="square" lIns="46799" tIns="46799" rIns="46799" bIns="46799" numCol="1" anchor="ctr">
+                <a:noAutofit/>
+              </a:bodyPr>
+              <a:lstStyle/>
+              <a:p>
+                <a:endParaRPr/>
+              </a:p>
+            </p:txBody>
+          </p:sp>
+          <p:sp>
+            <p:nvSpPr>
+              <p:cNvPr id="20" name="Oval">
+                <a:extLst>
+                  <a:ext uri="{FF2B5EF4-FFF2-40B4-BE49-F238E27FC236}">
+                    <a16:creationId xmlns:a16="http://schemas.microsoft.com/office/drawing/2014/main" id="{867224F0-77F4-DBFA-0B50-D01D92ABD3DE}"/>
+                  </a:ext>
+                </a:extLst>
+              </p:cNvPr>
+              <p:cNvSpPr/>
+              <p:nvPr/>
+            </p:nvSpPr>
+            <p:spPr>
+              <a:xfrm>
+                <a:off x="764605" y="2013925"/>
+                <a:ext cx="1270001" cy="388591"/>
+              </a:xfrm>
+              <a:prstGeom prst="ellipse">
+                <a:avLst/>
+              </a:prstGeom>
+              <a:solidFill>
+                <a:srgbClr val="FFFFFF"/>
+              </a:solidFill>
+              <a:ln w="25400" cap="flat">
+                <a:solidFill>
+                  <a:schemeClr val="accent1"/>
+                </a:solidFill>
+                <a:prstDash val="solid"/>
+                <a:round/>
+              </a:ln>
+              <a:effectLst/>
+            </p:spPr>
+            <p:txBody>
+              <a:bodyPr wrap="square" lIns="46799" tIns="46799" rIns="46799" bIns="46799" numCol="1" anchor="ctr">
+                <a:noAutofit/>
+              </a:bodyPr>
+              <a:lstStyle/>
+              <a:p>
+                <a:endParaRPr/>
+              </a:p>
+            </p:txBody>
+          </p:sp>
+          <p:sp>
+            <p:nvSpPr>
+              <p:cNvPr id="21" name="Line">
+                <a:extLst>
+                  <a:ext uri="{FF2B5EF4-FFF2-40B4-BE49-F238E27FC236}">
+                    <a16:creationId xmlns:a16="http://schemas.microsoft.com/office/drawing/2014/main" id="{7DE5E0C7-1EDE-95E8-B15D-83DCC1F6B63A}"/>
+                  </a:ext>
+                </a:extLst>
+              </p:cNvPr>
+              <p:cNvSpPr/>
+              <p:nvPr/>
+            </p:nvSpPr>
+            <p:spPr>
+              <a:xfrm flipV="1">
+                <a:off x="2034605" y="687525"/>
+                <a:ext cx="1" cy="1516901"/>
+              </a:xfrm>
+              <a:prstGeom prst="line">
+                <a:avLst/>
+              </a:prstGeom>
+              <a:noFill/>
+              <a:ln w="25400" cap="flat">
+                <a:solidFill>
+                  <a:schemeClr val="accent1"/>
+                </a:solidFill>
+                <a:prstDash val="solid"/>
+                <a:round/>
+              </a:ln>
+              <a:effectLst>
+                <a:outerShdw blurRad="38100" dist="20000" dir="5400000" rotWithShape="0">
+                  <a:srgbClr val="000000">
+                    <a:alpha val="38000"/>
+                  </a:srgbClr>
+                </a:outerShdw>
+              </a:effectLst>
+            </p:spPr>
+            <p:txBody>
+              <a:bodyPr wrap="square" lIns="45719" tIns="45719" rIns="45719" bIns="45719" numCol="1" anchor="t">
+                <a:noAutofit/>
+              </a:bodyPr>
+              <a:lstStyle/>
+              <a:p>
+                <a:endParaRPr/>
+              </a:p>
+            </p:txBody>
+          </p:sp>
+          <p:sp>
+            <p:nvSpPr>
+              <p:cNvPr id="22" name="Line">
+                <a:extLst>
+                  <a:ext uri="{FF2B5EF4-FFF2-40B4-BE49-F238E27FC236}">
+                    <a16:creationId xmlns:a16="http://schemas.microsoft.com/office/drawing/2014/main" id="{98A518C0-B70A-FCAD-2CBA-C9D85E8B4F74}"/>
+                  </a:ext>
+                </a:extLst>
+              </p:cNvPr>
+              <p:cNvSpPr/>
+              <p:nvPr/>
+            </p:nvSpPr>
+            <p:spPr>
+              <a:xfrm>
+                <a:off x="1679005" y="1541452"/>
+                <a:ext cx="1009660" cy="278637"/>
+              </a:xfrm>
+              <a:prstGeom prst="line">
+                <a:avLst/>
+              </a:prstGeom>
+              <a:noFill/>
+              <a:ln w="25400" cap="flat">
+                <a:solidFill>
+                  <a:schemeClr val="accent2">
+                    <a:lumOff val="11225"/>
+                  </a:schemeClr>
+                </a:solidFill>
+                <a:prstDash val="solid"/>
+                <a:round/>
+                <a:tailEnd type="triangle" w="med" len="med"/>
+              </a:ln>
+              <a:effectLst>
+                <a:outerShdw blurRad="38100" dist="20000" dir="5400000" rotWithShape="0">
+                  <a:srgbClr val="000000">
+                    <a:alpha val="38000"/>
+                  </a:srgbClr>
+                </a:outerShdw>
+              </a:effectLst>
+            </p:spPr>
+            <p:txBody>
+              <a:bodyPr wrap="square" lIns="45719" tIns="45719" rIns="45719" bIns="45719" numCol="1" anchor="t">
+                <a:noAutofit/>
+              </a:bodyPr>
+              <a:lstStyle/>
+              <a:p>
+                <a:endParaRPr/>
+              </a:p>
+            </p:txBody>
+          </p:sp>
+          <p:sp>
+            <p:nvSpPr>
+              <p:cNvPr id="23" name="Line">
+                <a:extLst>
+                  <a:ext uri="{FF2B5EF4-FFF2-40B4-BE49-F238E27FC236}">
+                    <a16:creationId xmlns:a16="http://schemas.microsoft.com/office/drawing/2014/main" id="{45CA9006-8EE6-2923-306B-289EF45BA156}"/>
+                  </a:ext>
+                </a:extLst>
+              </p:cNvPr>
+              <p:cNvSpPr/>
+              <p:nvPr/>
+            </p:nvSpPr>
+            <p:spPr>
+              <a:xfrm>
+                <a:off x="1463105" y="2141779"/>
+                <a:ext cx="183420" cy="847469"/>
+              </a:xfrm>
+              <a:prstGeom prst="line">
+                <a:avLst/>
+              </a:prstGeom>
+              <a:noFill/>
+              <a:ln w="25400" cap="flat">
+                <a:solidFill>
+                  <a:schemeClr val="accent2">
+                    <a:lumOff val="11225"/>
+                  </a:schemeClr>
+                </a:solidFill>
+                <a:prstDash val="solid"/>
+                <a:round/>
+                <a:tailEnd type="triangle" w="med" len="med"/>
+              </a:ln>
+              <a:effectLst>
+                <a:outerShdw blurRad="38100" dist="20000" dir="5400000" rotWithShape="0">
+                  <a:srgbClr val="000000">
+                    <a:alpha val="38000"/>
+                  </a:srgbClr>
+                </a:outerShdw>
+              </a:effectLst>
+            </p:spPr>
+            <p:txBody>
+              <a:bodyPr wrap="square" lIns="45719" tIns="45719" rIns="45719" bIns="45719" numCol="1" anchor="t">
+                <a:noAutofit/>
+              </a:bodyPr>
+              <a:lstStyle/>
+              <a:p>
+                <a:endParaRPr/>
+              </a:p>
+            </p:txBody>
+          </p:sp>
+          <p:sp>
+            <p:nvSpPr>
+              <p:cNvPr id="24" name="Line">
+                <a:extLst>
+                  <a:ext uri="{FF2B5EF4-FFF2-40B4-BE49-F238E27FC236}">
+                    <a16:creationId xmlns:a16="http://schemas.microsoft.com/office/drawing/2014/main" id="{1E68F7BA-008F-F7CF-BAC9-FB96921E3973}"/>
+                  </a:ext>
+                </a:extLst>
+              </p:cNvPr>
+              <p:cNvSpPr/>
+              <p:nvPr/>
+            </p:nvSpPr>
+            <p:spPr>
+              <a:xfrm flipH="1">
+                <a:off x="-1" y="1621079"/>
+                <a:ext cx="1005252" cy="737932"/>
+              </a:xfrm>
+              <a:prstGeom prst="line">
+                <a:avLst/>
+              </a:prstGeom>
+              <a:noFill/>
+              <a:ln w="25400" cap="flat">
+                <a:solidFill>
+                  <a:schemeClr val="accent2">
+                    <a:lumOff val="11225"/>
+                  </a:schemeClr>
+                </a:solidFill>
+                <a:prstDash val="solid"/>
+                <a:round/>
+                <a:tailEnd type="triangle" w="med" len="med"/>
+              </a:ln>
+              <a:effectLst>
+                <a:outerShdw blurRad="38100" dist="20000" dir="5400000" rotWithShape="0">
+                  <a:srgbClr val="000000">
+                    <a:alpha val="38000"/>
+                  </a:srgbClr>
+                </a:outerShdw>
+              </a:effectLst>
+            </p:spPr>
+            <p:txBody>
+              <a:bodyPr wrap="square" lIns="45719" tIns="45719" rIns="45719" bIns="45719" numCol="1" anchor="t">
+                <a:noAutofit/>
+              </a:bodyPr>
+              <a:lstStyle/>
+              <a:p>
+                <a:endParaRPr/>
+              </a:p>
+            </p:txBody>
+          </p:sp>
+          <p:sp>
+            <p:nvSpPr>
+              <p:cNvPr id="25" name="Line">
+                <a:extLst>
+                  <a:ext uri="{FF2B5EF4-FFF2-40B4-BE49-F238E27FC236}">
+                    <a16:creationId xmlns:a16="http://schemas.microsoft.com/office/drawing/2014/main" id="{7D5B3F52-A54A-BA53-8EDC-521008FF84E0}"/>
+                  </a:ext>
+                </a:extLst>
+              </p:cNvPr>
+              <p:cNvSpPr/>
+              <p:nvPr/>
+            </p:nvSpPr>
+            <p:spPr>
+              <a:xfrm flipH="1" flipV="1">
+                <a:off x="285891" y="655790"/>
+                <a:ext cx="746066" cy="578855"/>
+              </a:xfrm>
+              <a:prstGeom prst="line">
+                <a:avLst/>
+              </a:prstGeom>
+              <a:noFill/>
+              <a:ln w="25400" cap="flat">
+                <a:solidFill>
+                  <a:schemeClr val="accent2">
+                    <a:lumOff val="11225"/>
+                  </a:schemeClr>
+                </a:solidFill>
+                <a:prstDash val="solid"/>
+                <a:round/>
+                <a:tailEnd type="triangle" w="med" len="med"/>
+              </a:ln>
+              <a:effectLst>
+                <a:outerShdw blurRad="38100" dist="20000" dir="5400000" rotWithShape="0">
+                  <a:srgbClr val="000000">
+                    <a:alpha val="38000"/>
+                  </a:srgbClr>
+                </a:outerShdw>
+              </a:effectLst>
+            </p:spPr>
+            <p:txBody>
+              <a:bodyPr wrap="square" lIns="45719" tIns="45719" rIns="45719" bIns="45719" numCol="1" anchor="t">
+                <a:noAutofit/>
+              </a:bodyPr>
+              <a:lstStyle/>
+              <a:p>
+                <a:endParaRPr/>
+              </a:p>
+            </p:txBody>
+          </p:sp>
+          <p:sp>
+            <p:nvSpPr>
+              <p:cNvPr id="26" name="Line">
+                <a:extLst>
+                  <a:ext uri="{FF2B5EF4-FFF2-40B4-BE49-F238E27FC236}">
+                    <a16:creationId xmlns:a16="http://schemas.microsoft.com/office/drawing/2014/main" id="{C49E6E46-8AB3-79D9-62A2-8D44387369A5}"/>
+                  </a:ext>
+                </a:extLst>
+              </p:cNvPr>
+              <p:cNvSpPr/>
+              <p:nvPr/>
+            </p:nvSpPr>
+            <p:spPr>
+              <a:xfrm flipV="1">
+                <a:off x="1414937" y="0"/>
+                <a:ext cx="843472" cy="993883"/>
+              </a:xfrm>
+              <a:prstGeom prst="line">
+                <a:avLst/>
+              </a:prstGeom>
+              <a:noFill/>
+              <a:ln w="25400" cap="flat">
+                <a:solidFill>
+                  <a:schemeClr val="accent2">
+                    <a:lumOff val="11225"/>
+                  </a:schemeClr>
+                </a:solidFill>
+                <a:prstDash val="solid"/>
+                <a:round/>
+                <a:tailEnd type="triangle" w="med" len="med"/>
+              </a:ln>
+              <a:effectLst>
+                <a:outerShdw blurRad="38100" dist="20000" dir="5400000" rotWithShape="0">
+                  <a:srgbClr val="000000">
+                    <a:alpha val="38000"/>
+                  </a:srgbClr>
+                </a:outerShdw>
+              </a:effectLst>
+            </p:spPr>
+            <p:txBody>
+              <a:bodyPr wrap="square" lIns="45719" tIns="45719" rIns="45719" bIns="45719" numCol="1" anchor="t">
+                <a:noAutofit/>
+              </a:bodyPr>
+              <a:lstStyle/>
+              <a:p>
+                <a:endParaRPr/>
+              </a:p>
+            </p:txBody>
+          </p:sp>
+          <p:sp>
+            <p:nvSpPr>
+              <p:cNvPr id="27" name="Line">
+                <a:extLst>
+                  <a:ext uri="{FF2B5EF4-FFF2-40B4-BE49-F238E27FC236}">
+                    <a16:creationId xmlns:a16="http://schemas.microsoft.com/office/drawing/2014/main" id="{6F206599-1833-022C-ADF7-560A4C66231D}"/>
+                  </a:ext>
+                </a:extLst>
+              </p:cNvPr>
+              <p:cNvSpPr/>
+              <p:nvPr/>
+            </p:nvSpPr>
+            <p:spPr>
+              <a:xfrm flipH="1">
+                <a:off x="885178" y="1616183"/>
+                <a:ext cx="437443" cy="943513"/>
+              </a:xfrm>
+              <a:prstGeom prst="line">
+                <a:avLst/>
+              </a:prstGeom>
+              <a:noFill/>
+              <a:ln w="25400" cap="flat">
+                <a:solidFill>
+                  <a:schemeClr val="accent2">
+                    <a:lumOff val="11225"/>
+                  </a:schemeClr>
+                </a:solidFill>
+                <a:prstDash val="solid"/>
+                <a:round/>
+                <a:tailEnd type="triangle" w="med" len="med"/>
+              </a:ln>
+              <a:effectLst>
+                <a:outerShdw blurRad="38100" dist="20000" dir="5400000" rotWithShape="0">
+                  <a:srgbClr val="000000">
+                    <a:alpha val="38000"/>
+                  </a:srgbClr>
+                </a:outerShdw>
+              </a:effectLst>
+            </p:spPr>
+            <p:txBody>
+              <a:bodyPr wrap="square" lIns="45719" tIns="45719" rIns="45719" bIns="45719" numCol="1" anchor="t">
+                <a:noAutofit/>
+              </a:bodyPr>
+              <a:lstStyle/>
+              <a:p>
+                <a:endParaRPr/>
+              </a:p>
+            </p:txBody>
+          </p:sp>
+          <p:sp>
+            <p:nvSpPr>
+              <p:cNvPr id="28" name="Line">
+                <a:extLst>
+                  <a:ext uri="{FF2B5EF4-FFF2-40B4-BE49-F238E27FC236}">
+                    <a16:creationId xmlns:a16="http://schemas.microsoft.com/office/drawing/2014/main" id="{9F08F314-ED99-ABDE-2989-E16B76066C64}"/>
+                  </a:ext>
+                </a:extLst>
+              </p:cNvPr>
+              <p:cNvSpPr/>
+              <p:nvPr/>
+            </p:nvSpPr>
+            <p:spPr>
+              <a:xfrm flipV="1">
+                <a:off x="751905" y="687525"/>
+                <a:ext cx="1" cy="1516901"/>
+              </a:xfrm>
+              <a:prstGeom prst="line">
+                <a:avLst/>
+              </a:prstGeom>
+              <a:noFill/>
+              <a:ln w="25400" cap="flat">
+                <a:solidFill>
+                  <a:schemeClr val="accent1"/>
+                </a:solidFill>
+                <a:prstDash val="solid"/>
+                <a:round/>
+              </a:ln>
+              <a:effectLst>
+                <a:outerShdw blurRad="38100" dist="20000" dir="5400000" rotWithShape="0">
+                  <a:srgbClr val="000000">
+                    <a:alpha val="38000"/>
+                  </a:srgbClr>
+                </a:outerShdw>
+              </a:effectLst>
+            </p:spPr>
+            <p:txBody>
+              <a:bodyPr wrap="square" lIns="45719" tIns="45719" rIns="45719" bIns="45719" numCol="1" anchor="t">
+                <a:noAutofit/>
+              </a:bodyPr>
+              <a:lstStyle/>
+              <a:p>
+                <a:endParaRPr/>
+              </a:p>
+            </p:txBody>
+          </p:sp>
+        </p:grpSp>
+        <p:grpSp>
+          <p:nvGrpSpPr>
+            <p:cNvPr id="29" name="Group">
+              <a:extLst>
+                <a:ext uri="{FF2B5EF4-FFF2-40B4-BE49-F238E27FC236}">
+                  <a16:creationId xmlns:a16="http://schemas.microsoft.com/office/drawing/2014/main" id="{3BCB4052-B2DF-7FBE-67CA-27B7FC8E0000}"/>
+                </a:ext>
+              </a:extLst>
+            </p:cNvPr>
+            <p:cNvGrpSpPr/>
+            <p:nvPr/>
+          </p:nvGrpSpPr>
+          <p:grpSpPr>
+            <a:xfrm>
+              <a:off x="10344149" y="222901"/>
+              <a:ext cx="309606" cy="1166292"/>
+              <a:chOff x="0" y="0"/>
+              <a:chExt cx="309604" cy="1166291"/>
+            </a:xfrm>
+          </p:grpSpPr>
+          <p:sp>
+            <p:nvSpPr>
+              <p:cNvPr id="30" name="Line">
+                <a:extLst>
+                  <a:ext uri="{FF2B5EF4-FFF2-40B4-BE49-F238E27FC236}">
+                    <a16:creationId xmlns:a16="http://schemas.microsoft.com/office/drawing/2014/main" id="{C822536E-EB47-9F06-D35B-5C5557A8DEE6}"/>
+                  </a:ext>
+                </a:extLst>
+              </p:cNvPr>
+              <p:cNvSpPr/>
+              <p:nvPr/>
+            </p:nvSpPr>
+            <p:spPr>
+              <a:xfrm flipV="1">
+                <a:off x="12621" y="0"/>
+                <a:ext cx="1" cy="896945"/>
+              </a:xfrm>
+              <a:prstGeom prst="line">
+                <a:avLst/>
+              </a:prstGeom>
+              <a:noFill/>
+              <a:ln w="25400" cap="flat">
+                <a:solidFill>
+                  <a:schemeClr val="accent1"/>
+                </a:solidFill>
+                <a:prstDash val="solid"/>
+                <a:round/>
+              </a:ln>
+              <a:effectLst>
+                <a:outerShdw blurRad="38100" dist="20000" dir="5400000" rotWithShape="0">
+                  <a:srgbClr val="000000">
+                    <a:alpha val="38000"/>
+                  </a:srgbClr>
+                </a:outerShdw>
+              </a:effectLst>
+            </p:spPr>
+            <p:txBody>
+              <a:bodyPr wrap="square" lIns="45719" tIns="45719" rIns="45719" bIns="45719" numCol="1" anchor="t">
+                <a:noAutofit/>
+              </a:bodyPr>
+              <a:lstStyle/>
+              <a:p>
+                <a:endParaRPr/>
+              </a:p>
+            </p:txBody>
+          </p:sp>
+          <p:sp>
+            <p:nvSpPr>
+              <p:cNvPr id="31" name="Line">
+                <a:extLst>
+                  <a:ext uri="{FF2B5EF4-FFF2-40B4-BE49-F238E27FC236}">
+                    <a16:creationId xmlns:a16="http://schemas.microsoft.com/office/drawing/2014/main" id="{090FC745-4B87-E286-1ED8-1C1DB1856F02}"/>
+                  </a:ext>
+                </a:extLst>
+              </p:cNvPr>
+              <p:cNvSpPr/>
+              <p:nvPr/>
+            </p:nvSpPr>
+            <p:spPr>
+              <a:xfrm flipV="1">
+                <a:off x="302907" y="269346"/>
+                <a:ext cx="1" cy="896946"/>
+              </a:xfrm>
+              <a:prstGeom prst="line">
+                <a:avLst/>
+              </a:prstGeom>
+              <a:noFill/>
+              <a:ln w="25400" cap="flat">
+                <a:solidFill>
+                  <a:schemeClr val="accent1"/>
+                </a:solidFill>
+                <a:prstDash val="solid"/>
+                <a:round/>
+              </a:ln>
+              <a:effectLst>
+                <a:outerShdw blurRad="38100" dist="20000" dir="5400000" rotWithShape="0">
+                  <a:srgbClr val="000000">
+                    <a:alpha val="38000"/>
+                  </a:srgbClr>
+                </a:outerShdw>
+              </a:effectLst>
+            </p:spPr>
+            <p:txBody>
+              <a:bodyPr wrap="square" lIns="45719" tIns="45719" rIns="45719" bIns="45719" numCol="1" anchor="t">
+                <a:noAutofit/>
+              </a:bodyPr>
+              <a:lstStyle/>
+              <a:p>
+                <a:endParaRPr/>
+              </a:p>
+            </p:txBody>
+          </p:sp>
+          <p:sp>
+            <p:nvSpPr>
+              <p:cNvPr id="32" name="Line">
+                <a:extLst>
+                  <a:ext uri="{FF2B5EF4-FFF2-40B4-BE49-F238E27FC236}">
+                    <a16:creationId xmlns:a16="http://schemas.microsoft.com/office/drawing/2014/main" id="{B04DB464-08FA-5140-5FA9-59C00B15DBF8}"/>
+                  </a:ext>
+                </a:extLst>
+              </p:cNvPr>
+              <p:cNvSpPr/>
+              <p:nvPr/>
+            </p:nvSpPr>
+            <p:spPr>
+              <a:xfrm flipH="1" flipV="1">
+                <a:off x="-1" y="-1"/>
+                <a:ext cx="296985" cy="275562"/>
+              </a:xfrm>
+              <a:prstGeom prst="line">
+                <a:avLst/>
+              </a:prstGeom>
+              <a:noFill/>
+              <a:ln w="25400" cap="flat">
+                <a:solidFill>
+                  <a:schemeClr val="accent1"/>
+                </a:solidFill>
+                <a:prstDash val="solid"/>
+                <a:round/>
+              </a:ln>
+              <a:effectLst>
+                <a:outerShdw blurRad="38100" dist="20000" dir="5400000" rotWithShape="0">
+                  <a:srgbClr val="000000">
+                    <a:alpha val="38000"/>
+                  </a:srgbClr>
+                </a:outerShdw>
+              </a:effectLst>
+            </p:spPr>
+            <p:txBody>
+              <a:bodyPr wrap="square" lIns="45719" tIns="45719" rIns="45719" bIns="45719" numCol="1" anchor="t">
+                <a:noAutofit/>
+              </a:bodyPr>
+              <a:lstStyle/>
+              <a:p>
+                <a:endParaRPr/>
+              </a:p>
+            </p:txBody>
+          </p:sp>
+          <p:sp>
+            <p:nvSpPr>
+              <p:cNvPr id="33" name="Line">
+                <a:extLst>
+                  <a:ext uri="{FF2B5EF4-FFF2-40B4-BE49-F238E27FC236}">
+                    <a16:creationId xmlns:a16="http://schemas.microsoft.com/office/drawing/2014/main" id="{CB226066-3829-899C-E638-4C6607C37EDA}"/>
+                  </a:ext>
+                </a:extLst>
+              </p:cNvPr>
+              <p:cNvSpPr/>
+              <p:nvPr/>
+            </p:nvSpPr>
+            <p:spPr>
+              <a:xfrm flipH="1" flipV="1">
+                <a:off x="12621" y="890014"/>
+                <a:ext cx="296984" cy="275562"/>
+              </a:xfrm>
+              <a:prstGeom prst="line">
+                <a:avLst/>
+              </a:prstGeom>
+              <a:noFill/>
+              <a:ln w="25400" cap="flat">
+                <a:solidFill>
+                  <a:schemeClr val="accent1"/>
+                </a:solidFill>
+                <a:prstDash val="solid"/>
+                <a:round/>
+              </a:ln>
+              <a:effectLst>
+                <a:outerShdw blurRad="38100" dist="20000" dir="5400000" rotWithShape="0">
+                  <a:srgbClr val="000000">
+                    <a:alpha val="38000"/>
+                  </a:srgbClr>
+                </a:outerShdw>
+              </a:effectLst>
+            </p:spPr>
+            <p:txBody>
+              <a:bodyPr wrap="square" lIns="45719" tIns="45719" rIns="45719" bIns="45719" numCol="1" anchor="t">
+                <a:noAutofit/>
+              </a:bodyPr>
+              <a:lstStyle/>
+              <a:p>
+                <a:endParaRPr/>
+              </a:p>
+            </p:txBody>
+          </p:sp>
+        </p:grpSp>
+        <p:pic>
+          <p:nvPicPr>
+            <p:cNvPr id="34" name="dist.pdf" descr="dist.pdf">
+              <a:extLst>
+                <a:ext uri="{FF2B5EF4-FFF2-40B4-BE49-F238E27FC236}">
+                  <a16:creationId xmlns:a16="http://schemas.microsoft.com/office/drawing/2014/main" id="{9A724F7F-9296-76AB-21F3-8F1466C1F0E7}"/>
+                </a:ext>
+              </a:extLst>
+            </p:cNvPr>
+            <p:cNvPicPr>
+              <a:picLocks noChangeAspect="1"/>
+            </p:cNvPicPr>
+            <p:nvPr/>
+          </p:nvPicPr>
+          <p:blipFill>
+            <a:blip r:embed="rId4"/>
+            <a:stretch>
+              <a:fillRect/>
+            </a:stretch>
+          </p:blipFill>
+          <p:spPr>
+            <a:xfrm rot="20488059">
+              <a:off x="6626643" y="2446270"/>
+              <a:ext cx="414703" cy="182752"/>
+            </a:xfrm>
+            <a:prstGeom prst="rect">
+              <a:avLst/>
+            </a:prstGeom>
+            <a:ln w="12700">
+              <a:miter lim="400000"/>
+            </a:ln>
+          </p:spPr>
+        </p:pic>
+        <p:pic>
+          <p:nvPicPr>
+            <p:cNvPr id="35" name="latex-image.pdf" descr="latex-image.pdf">
+              <a:extLst>
+                <a:ext uri="{FF2B5EF4-FFF2-40B4-BE49-F238E27FC236}">
+                  <a16:creationId xmlns:a16="http://schemas.microsoft.com/office/drawing/2014/main" id="{61E1BC94-C5B2-70A6-E30B-9C695374E2CF}"/>
+                </a:ext>
+              </a:extLst>
+            </p:cNvPr>
+            <p:cNvPicPr>
+              <a:picLocks/>
+            </p:cNvPicPr>
+            <p:nvPr/>
+          </p:nvPicPr>
+          <p:blipFill>
+            <a:blip r:embed="rId5"/>
+            <a:stretch>
+              <a:fillRect/>
+            </a:stretch>
+          </p:blipFill>
+          <p:spPr>
+            <a:xfrm rot="4260423">
+              <a:off x="6602362" y="-1830899"/>
+              <a:ext cx="394651" cy="8043728"/>
+            </a:xfrm>
+            <a:prstGeom prst="rect">
+              <a:avLst/>
+            </a:prstGeom>
+            <a:ln w="12700">
+              <a:miter lim="400000"/>
+            </a:ln>
+          </p:spPr>
+        </p:pic>
+        <p:sp>
+          <p:nvSpPr>
+            <p:cNvPr id="36" name="E.g. the beamport?">
+              <a:extLst>
+                <a:ext uri="{FF2B5EF4-FFF2-40B4-BE49-F238E27FC236}">
+                  <a16:creationId xmlns:a16="http://schemas.microsoft.com/office/drawing/2014/main" id="{2B16B89D-5815-BFD9-631B-7056D273D624}"/>
+                </a:ext>
+              </a:extLst>
+            </p:cNvPr>
+            <p:cNvSpPr txBox="1"/>
+            <p:nvPr/>
+          </p:nvSpPr>
+          <p:spPr>
+            <a:xfrm>
+              <a:off x="9502644" y="1725347"/>
+              <a:ext cx="2416503" cy="337436"/>
+            </a:xfrm>
+            <a:prstGeom prst="rect">
+              <a:avLst/>
+            </a:prstGeom>
+            <a:ln w="12700">
+              <a:miter lim="400000"/>
+            </a:ln>
+            <a:extLst>
+              <a:ext uri="{C572A759-6A51-4108-AA02-DFA0A04FC94B}">
+                <ma14:wrappingTextBoxFlag xmlns:ma14="http://schemas.microsoft.com/office/mac/drawingml/2011/main" xmlns:a14="http://schemas.microsoft.com/office/drawing/2010/main" xmlns:m="http://schemas.openxmlformats.org/officeDocument/2006/math" xmlns="" val="1"/>
+              </a:ext>
+            </a:extLst>
+          </p:spPr>
+          <p:txBody>
+            <a:bodyPr wrap="none" lIns="0" tIns="0" rIns="0" bIns="0">
+              <a:spAutoFit/>
+            </a:bodyPr>
+            <a:lstStyle/>
+            <a:p>
+              <a:r>
+                <a:rPr sz="1200" dirty="0"/>
+                <a:t>E.g. the </a:t>
+              </a:r>
+              <a:r>
+                <a:rPr sz="1200" dirty="0" err="1"/>
+                <a:t>beamport</a:t>
+              </a:r>
+              <a:r>
+                <a:rPr sz="1200" dirty="0"/>
+                <a:t>?</a:t>
+              </a:r>
+            </a:p>
+          </p:txBody>
+        </p:sp>
+        <p:pic>
+          <p:nvPicPr>
+            <p:cNvPr id="37" name="Omega.pdf" descr="Omega.pdf">
+              <a:extLst>
+                <a:ext uri="{FF2B5EF4-FFF2-40B4-BE49-F238E27FC236}">
+                  <a16:creationId xmlns:a16="http://schemas.microsoft.com/office/drawing/2014/main" id="{6D199632-F641-8E4B-C455-EE059862AEA0}"/>
+                </a:ext>
+              </a:extLst>
+            </p:cNvPr>
+            <p:cNvPicPr>
+              <a:picLocks noChangeAspect="1"/>
+            </p:cNvPicPr>
+            <p:nvPr/>
+          </p:nvPicPr>
+          <p:blipFill>
+            <a:blip r:embed="rId6"/>
+            <a:stretch>
+              <a:fillRect/>
+            </a:stretch>
+          </p:blipFill>
+          <p:spPr>
+            <a:xfrm>
+              <a:off x="11551919" y="574542"/>
+              <a:ext cx="181748" cy="204465"/>
+            </a:xfrm>
+            <a:prstGeom prst="rect">
+              <a:avLst/>
+            </a:prstGeom>
+            <a:ln w="12700">
+              <a:miter lim="400000"/>
+            </a:ln>
+          </p:spPr>
+        </p:pic>
+        <p:sp>
+          <p:nvSpPr>
+            <p:cNvPr id="38" name="Line">
+              <a:extLst>
+                <a:ext uri="{FF2B5EF4-FFF2-40B4-BE49-F238E27FC236}">
+                  <a16:creationId xmlns:a16="http://schemas.microsoft.com/office/drawing/2014/main" id="{FFC5BDA7-868F-C1C0-DEE4-6965B89B0E38}"/>
+                </a:ext>
+              </a:extLst>
+            </p:cNvPr>
+            <p:cNvSpPr/>
+            <p:nvPr/>
+          </p:nvSpPr>
+          <p:spPr>
+            <a:xfrm>
+              <a:off x="11005376" y="676737"/>
+              <a:ext cx="509141" cy="1"/>
+            </a:xfrm>
+            <a:prstGeom prst="line">
+              <a:avLst/>
+            </a:prstGeom>
+            <a:ln w="25400">
+              <a:solidFill>
+                <a:schemeClr val="accent1"/>
+              </a:solidFill>
+              <a:tailEnd type="triangle"/>
+            </a:ln>
+            <a:effectLst>
+              <a:outerShdw blurRad="38100" dist="20000" dir="5400000" rotWithShape="0">
+                <a:srgbClr val="000000">
+                  <a:alpha val="38000"/>
+                </a:srgbClr>
+              </a:outerShdw>
+            </a:effectLst>
+          </p:spPr>
+          <p:txBody>
+            <a:bodyPr lIns="45719" rIns="45719"/>
+            <a:lstStyle/>
+            <a:p>
+              <a:endParaRPr/>
+            </a:p>
+          </p:txBody>
+        </p:sp>
+      </p:grpSp>
     </p:spTree>
   </p:cSld>
   <p:clrMapOvr>

</xml_diff>